<commit_message>
lec-2026: fix clipped/overflowing figure text (benchmarks, timeline); timeline outcomes and .746; reword exploratory tiles; deck v5 captions fitted
</commit_message>
<xml_diff>
--- a/lec-2026/assets/Monnot_Poster_v5.pptx
+++ b/lec-2026/assets/Monnot_Poster_v5.pptx
@@ -3726,7 +3726,7 @@
                 <a:ea typeface="Segoe UI"/>
                 <a:cs typeface="Segoe UI"/>
               </a:rPr>
-              <a:t>Six frozen prompt architectures were scored once on the 55-case development set against bars locked to the human interval (Agency ≥ .910; Others ≥ .805). Every prompt was disqualified on false positives. Agency PSA sat at .750–.798. Study 1 stays on the human composite. No test case was scored before those results were fixed; one later 65-case look: Agency .81, Others .75–.77, still disqualified; 128 sealed.</a:t>
+              <a:t>Six frozen prompt architectures were scored once on the 55-case development set against bars locked to the human interval (Agency ≥ .910; Others ≥ .805). Every prompt was disqualified on false positives. Agency PSA sat at .750–.798. Study 1 stays on the human composite. No test case was scored before those results were fixed; one later 65-case look: Agency .81, Others .746–.770, still disqualified; 128 sealed.</a:t>
             </a:r>
           </a:p>
         </p:txBody>
@@ -4117,7 +4117,7 @@
         <p:spPr>
           <a:xfrm>
             <a:off x="365760" y="1170432"/>
-            <a:ext cx="9326880" cy="4472872"/>
+            <a:ext cx="9326880" cy="4472871"/>
           </a:xfrm>
           <a:prstGeom prst="rect">
             <a:avLst/>
@@ -4132,8 +4132,8 @@
         </p:nvSpPr>
         <p:spPr>
           <a:xfrm>
-            <a:off x="384048" y="6839712"/>
-            <a:ext cx="9290304" cy="475488"/>
+            <a:off x="384048" y="5753031"/>
+            <a:ext cx="9290304" cy="1580456"/>
           </a:xfrm>
           <a:prstGeom prst="rect">
             <a:avLst/>
@@ -6224,7 +6224,7 @@
         <p:spPr>
           <a:xfrm>
             <a:off x="365760" y="1170432"/>
-            <a:ext cx="9326880" cy="3750131"/>
+            <a:ext cx="9326880" cy="3750130"/>
           </a:xfrm>
           <a:prstGeom prst="rect">
             <a:avLst/>
@@ -6239,8 +6239,8 @@
         </p:nvSpPr>
         <p:spPr>
           <a:xfrm>
-            <a:off x="384048" y="6839712"/>
-            <a:ext cx="9290304" cy="475488"/>
+            <a:off x="384048" y="5030290"/>
+            <a:ext cx="9290304" cy="2303197"/>
           </a:xfrm>
           <a:prstGeom prst="rect">
             <a:avLst/>
@@ -6581,7 +6581,7 @@
         <p:spPr>
           <a:xfrm>
             <a:off x="365760" y="1170432"/>
-            <a:ext cx="9326880" cy="2989677"/>
+            <a:ext cx="9326880" cy="2989676"/>
           </a:xfrm>
           <a:prstGeom prst="rect">
             <a:avLst/>
@@ -6596,8 +6596,8 @@
         </p:nvSpPr>
         <p:spPr>
           <a:xfrm>
-            <a:off x="384048" y="6839712"/>
-            <a:ext cx="9290304" cy="475488"/>
+            <a:off x="384048" y="4269836"/>
+            <a:ext cx="9290304" cy="3063652"/>
           </a:xfrm>
           <a:prstGeom prst="rect">
             <a:avLst/>
@@ -6953,8 +6953,8 @@
         </p:nvSpPr>
         <p:spPr>
           <a:xfrm>
-            <a:off x="384048" y="6839712"/>
-            <a:ext cx="9290304" cy="475488"/>
+            <a:off x="384048" y="5472398"/>
+            <a:ext cx="9290304" cy="1861089"/>
           </a:xfrm>
           <a:prstGeom prst="rect">
             <a:avLst/>
@@ -7294,8 +7294,8 @@
         </p:blipFill>
         <p:spPr>
           <a:xfrm>
-            <a:off x="365760" y="1170432"/>
-            <a:ext cx="9326880" cy="6733336"/>
+            <a:off x="1261040" y="1170432"/>
+            <a:ext cx="7536319" cy="5440680"/>
           </a:xfrm>
           <a:prstGeom prst="rect">
             <a:avLst/>
@@ -7310,8 +7310,8 @@
         </p:nvSpPr>
         <p:spPr>
           <a:xfrm>
-            <a:off x="384048" y="6839712"/>
-            <a:ext cx="9290304" cy="475488"/>
+            <a:off x="384048" y="6720840"/>
+            <a:ext cx="9290304" cy="612647"/>
           </a:xfrm>
           <a:prstGeom prst="rect">
             <a:avLst/>
@@ -7667,8 +7667,8 @@
         </p:nvSpPr>
         <p:spPr>
           <a:xfrm>
-            <a:off x="384048" y="6839712"/>
-            <a:ext cx="9290304" cy="475488"/>
+            <a:off x="384048" y="5309186"/>
+            <a:ext cx="9290304" cy="2024301"/>
           </a:xfrm>
           <a:prstGeom prst="rect">
             <a:avLst/>
@@ -9295,8 +9295,8 @@
         </p:nvSpPr>
         <p:spPr>
           <a:xfrm>
-            <a:off x="384048" y="6839712"/>
-            <a:ext cx="9290304" cy="475488"/>
+            <a:off x="384048" y="6629400"/>
+            <a:ext cx="9290304" cy="704087"/>
           </a:xfrm>
           <a:prstGeom prst="rect">
             <a:avLst/>
@@ -9973,8 +9973,8 @@
         </p:nvSpPr>
         <p:spPr>
           <a:xfrm>
-            <a:off x="384048" y="6839712"/>
-            <a:ext cx="9290304" cy="475488"/>
+            <a:off x="384048" y="6629400"/>
+            <a:ext cx="9290304" cy="704087"/>
           </a:xfrm>
           <a:prstGeom prst="rect">
             <a:avLst/>
@@ -10330,8 +10330,8 @@
         </p:nvSpPr>
         <p:spPr>
           <a:xfrm>
-            <a:off x="384048" y="6839712"/>
-            <a:ext cx="9290304" cy="475488"/>
+            <a:off x="384048" y="6629400"/>
+            <a:ext cx="9290304" cy="704087"/>
           </a:xfrm>
           <a:prstGeom prst="rect">
             <a:avLst/>

</xml_diff>

<commit_message>
lec-2026: poster tiles follow the design page (takeaway headers, prompt dot plot, people-unit competence figure, pathway color rules)
</commit_message>
<xml_diff>
--- a/lec-2026/assets/Monnot_Poster_v5.pptx
+++ b/lec-2026/assets/Monnot_Poster_v5.pptx
@@ -3224,7 +3224,7 @@
               </a:spcAft>
             </a:pPr>
             <a:r>
-              <a:rPr sz="3200" b="1" i="0">
+              <a:rPr sz="3000" b="1" i="0">
                 <a:solidFill>
                   <a:srgbClr val="FFFFFF"/>
                 </a:solidFill>
@@ -3644,20 +3644,17 @@
           <a:lstStyle/>
           <a:p>
             <a:pPr algn="l">
-              <a:lnSpc>
-                <a:spcPct val="100000"/>
-              </a:lnSpc>
               <a:spcBef>
                 <a:spcPts val="0"/>
               </a:spcBef>
               <a:spcAft>
-                <a:spcPts val="0"/>
-              </a:spcAft>
-            </a:pPr>
-            <a:r>
-              <a:rPr sz="3000" b="1" i="0">
-                <a:solidFill>
-                  <a:srgbClr val="FFFFFF"/>
+                <a:spcPts val="200"/>
+              </a:spcAft>
+            </a:pPr>
+            <a:r>
+              <a:rPr sz="1300" b="1" i="0">
+                <a:solidFill>
+                  <a:srgbClr val="E4F2F2"/>
                 </a:solidFill>
                 <a:latin typeface="Segoe UI"/>
                 <a:ea typeface="Segoe UI"/>
@@ -3679,7 +3676,7 @@
               </a:spcAft>
             </a:pPr>
             <a:r>
-              <a:rPr sz="3000" b="1" i="0">
+              <a:rPr sz="2700" b="1" i="0">
                 <a:solidFill>
                   <a:srgbClr val="FFFFFF"/>
                 </a:solidFill>
@@ -3687,50 +3684,35 @@
                 <a:ea typeface="Segoe UI"/>
                 <a:cs typeface="Segoe UI"/>
               </a:rPr>
-              <a:t>The one-shot failed. Human gold stayed.</a:t>
-            </a:r>
-          </a:p>
-        </p:txBody>
-      </p:sp>
-      <p:sp>
-        <p:nvSpPr>
-          <p:cNvPr id="5" name="TextBox 4"/>
-          <p:cNvSpPr txBox="1"/>
-          <p:nvPr/>
-        </p:nvSpPr>
-        <p:spPr>
-          <a:xfrm>
-            <a:off x="438912" y="1170432"/>
-            <a:ext cx="9189720" cy="1965960"/>
-          </a:xfrm>
-          <a:prstGeom prst="rect">
-            <a:avLst/>
-          </a:prstGeom>
-          <a:noFill/>
-        </p:spPr>
-        <p:txBody>
-          <a:bodyPr wrap="square" lIns="36576" rIns="36576" tIns="18288" bIns="18288" anchor="t"/>
-          <a:lstStyle/>
-          <a:p>
-            <a:pPr algn="l">
-              <a:spcAft>
-                <a:spcPts val="0"/>
-              </a:spcAft>
-            </a:pPr>
-            <a:r>
-              <a:rPr sz="2000" b="0" i="0">
-                <a:solidFill>
-                  <a:srgbClr val="333333"/>
-                </a:solidFill>
-                <a:latin typeface="Segoe UI"/>
-                <a:ea typeface="Segoe UI"/>
-                <a:cs typeface="Segoe UI"/>
-              </a:rPr>
-              <a:t>Six frozen prompt architectures were scored once on the 55-case development set against bars locked to the human interval (Agency ≥ .910; Others ≥ .805). Every prompt was disqualified on false positives. Agency PSA sat at .750–.798. Study 1 stays on the human composite. No test case was scored before those results were fixed; one later 65-case look: Agency .81, Others .746–.770, still disqualified; 128 sealed.</a:t>
-            </a:r>
-          </a:p>
-        </p:txBody>
-      </p:sp>
+              <a:t>No engineered prompt met the human bar</a:t>
+            </a:r>
+          </a:p>
+        </p:txBody>
+      </p:sp>
+      <p:pic>
+        <p:nvPicPr>
+          <p:cNvPr id="5" name="Picture 4" descr="fig_prompts.png"/>
+          <p:cNvPicPr>
+            <a:picLocks noChangeAspect="1"/>
+          </p:cNvPicPr>
+          <p:nvPr/>
+        </p:nvPicPr>
+        <p:blipFill>
+          <a:blip r:embed="rId2"/>
+          <a:stretch>
+            <a:fillRect/>
+          </a:stretch>
+        </p:blipFill>
+        <p:spPr>
+          <a:xfrm>
+            <a:off x="365760" y="1170432"/>
+            <a:ext cx="9326880" cy="5349240"/>
+          </a:xfrm>
+          <a:prstGeom prst="rect">
+            <a:avLst/>
+          </a:prstGeom>
+        </p:spPr>
+      </p:pic>
       <p:sp>
         <p:nvSpPr>
           <p:cNvPr id="6" name="TextBox 5"/>
@@ -3739,8 +3721,8 @@
         </p:nvSpPr>
         <p:spPr>
           <a:xfrm>
-            <a:off x="457200" y="3273552"/>
-            <a:ext cx="9144000" cy="3840480"/>
+            <a:off x="384048" y="6629400"/>
+            <a:ext cx="9290304" cy="704087"/>
           </a:xfrm>
           <a:prstGeom prst="rect">
             <a:avLst/>
@@ -3748,16 +3730,16 @@
           <a:noFill/>
         </p:spPr>
         <p:txBody>
-          <a:bodyPr wrap="square" lIns="18288" rIns="54864" tIns="18288" bIns="18288" anchor="t"/>
+          <a:bodyPr wrap="square" lIns="36576" rIns="36576" tIns="18288" bIns="18288" anchor="t"/>
           <a:lstStyle/>
           <a:p>
             <a:pPr algn="l">
               <a:spcAft>
-                <a:spcPts val="1400"/>
-              </a:spcAft>
-            </a:pPr>
-            <a:r>
-              <a:rPr sz="2000" b="0" i="0">
+                <a:spcPts val="0"/>
+              </a:spcAft>
+            </a:pPr>
+            <a:r>
+              <a:rPr sz="1200" b="0" i="1">
                 <a:solidFill>
                   <a:srgbClr val="333333"/>
                 </a:solidFill>
@@ -3765,43 +3747,7 @@
                 <a:ea typeface="Segoe UI"/>
                 <a:cs typeface="Segoe UI"/>
               </a:rPr>
-              <a:t>•  Communion and Self had no acceptance bar: human PSA was too low to validate against.</a:t>
-            </a:r>
-          </a:p>
-          <a:p>
-            <a:pPr algn="l">
-              <a:spcAft>
-                <a:spcPts val="1400"/>
-              </a:spcAft>
-            </a:pPr>
-            <a:r>
-              <a:rPr sz="2000" b="0" i="0">
-                <a:solidFill>
-                  <a:srgbClr val="333333"/>
-                </a:solidFill>
-                <a:latin typeface="Segoe UI"/>
-                <a:ea typeface="Segoe UI"/>
-                <a:cs typeface="Segoe UI"/>
-              </a:rPr>
-              <a:t>•  A prompt tuned to this pair would export communion PSA .48 into every later corpus.</a:t>
-            </a:r>
-          </a:p>
-          <a:p>
-            <a:pPr algn="l">
-              <a:spcAft>
-                <a:spcPts val="1400"/>
-              </a:spcAft>
-            </a:pPr>
-            <a:r>
-              <a:rPr sz="2000" b="0" i="0">
-                <a:solidFill>
-                  <a:srgbClr val="333333"/>
-                </a:solidFill>
-                <a:latin typeface="Segoe UI"/>
-                <a:ea typeface="Segoe UI"/>
-                <a:cs typeface="Segoe UI"/>
-              </a:rPr>
-              <a:t>•  The independent no-gold panel (ADR 0010) is a separate instrument, still unfrozen.</a:t>
+              <a:t>Six frozen prompts, scored once on the 55-case development set; each also produced false positives on cells both humans coded absent, which disqualified it. Communion and Self had no bar: human agreement was too low to validate against. A later 65-case look at the two best prompts landed in the same place (Agency .81; Others .746–.770); 128 test cases stay sealed. Study 1 runs on the human codes.</a:t>
             </a:r>
           </a:p>
         </p:txBody>
@@ -4052,20 +3998,17 @@
           <a:lstStyle/>
           <a:p>
             <a:pPr algn="l">
-              <a:lnSpc>
-                <a:spcPct val="100000"/>
-              </a:lnSpc>
               <a:spcBef>
                 <a:spcPts val="0"/>
               </a:spcBef>
               <a:spcAft>
-                <a:spcPts val="0"/>
-              </a:spcAft>
-            </a:pPr>
-            <a:r>
-              <a:rPr sz="3000" b="1" i="0">
-                <a:solidFill>
-                  <a:srgbClr val="FFFFFF"/>
+                <a:spcPts val="200"/>
+              </a:spcAft>
+            </a:pPr>
+            <a:r>
+              <a:rPr sz="1300" b="1" i="0">
+                <a:solidFill>
+                  <a:srgbClr val="E4F2F2"/>
                 </a:solidFill>
                 <a:latin typeface="Segoe UI"/>
                 <a:ea typeface="Segoe UI"/>
@@ -4087,7 +4030,7 @@
               </a:spcAft>
             </a:pPr>
             <a:r>
-              <a:rPr sz="3000" b="1" i="0">
+              <a:rPr sz="2700" b="1" i="0">
                 <a:solidFill>
                   <a:srgbClr val="FFFFFF"/>
                 </a:solidFill>
@@ -4452,6 +4395,27 @@
           <a:lstStyle/>
           <a:p>
             <a:pPr algn="l">
+              <a:spcBef>
+                <a:spcPts val="0"/>
+              </a:spcBef>
+              <a:spcAft>
+                <a:spcPts val="200"/>
+              </a:spcAft>
+            </a:pPr>
+            <a:r>
+              <a:rPr sz="1300" b="1" i="0">
+                <a:solidFill>
+                  <a:srgbClr val="FFFFFF"/>
+                </a:solidFill>
+                <a:latin typeface="Segoe UI"/>
+                <a:ea typeface="Segoe UI"/>
+                <a:cs typeface="Segoe UI"/>
+              </a:rPr>
+              <a:t>ACTION</a:t>
+            </a:r>
+          </a:p>
+          <a:p>
+            <a:pPr algn="l">
               <a:lnSpc>
                 <a:spcPct val="100000"/>
               </a:lnSpc>
@@ -4463,7 +4427,7 @@
               </a:spcAft>
             </a:pPr>
             <a:r>
-              <a:rPr sz="3200" b="1" i="0">
+              <a:rPr sz="2700" b="1" i="0">
                 <a:solidFill>
                   <a:srgbClr val="FFFFFF"/>
                 </a:solidFill>
@@ -4471,7 +4435,7 @@
                 <a:ea typeface="Segoe UI"/>
                 <a:cs typeface="Segoe UI"/>
               </a:rPr>
-              <a:t>TRY THIS QUARTER</a:t>
+              <a:t>Three things to do this quarter</a:t>
             </a:r>
           </a:p>
         </p:txBody>
@@ -5124,6 +5088,27 @@
           <a:lstStyle/>
           <a:p>
             <a:pPr algn="l">
+              <a:spcBef>
+                <a:spcPts val="0"/>
+              </a:spcBef>
+              <a:spcAft>
+                <a:spcPts val="200"/>
+              </a:spcAft>
+            </a:pPr>
+            <a:r>
+              <a:rPr sz="1300" b="1" i="0">
+                <a:solidFill>
+                  <a:srgbClr val="E4F2F2"/>
+                </a:solidFill>
+                <a:latin typeface="Segoe UI"/>
+                <a:ea typeface="Segoe UI"/>
+                <a:cs typeface="Segoe UI"/>
+              </a:rPr>
+              <a:t>NEXT</a:t>
+            </a:r>
+          </a:p>
+          <a:p>
+            <a:pPr algn="l">
               <a:lnSpc>
                 <a:spcPct val="100000"/>
               </a:lnSpc>
@@ -5135,7 +5120,7 @@
               </a:spcAft>
             </a:pPr>
             <a:r>
-              <a:rPr sz="3200" b="1" i="0">
+              <a:rPr sz="2700" b="1" i="0">
                 <a:solidFill>
                   <a:srgbClr val="FFFFFF"/>
                 </a:solidFill>
@@ -5143,7 +5128,7 @@
                 <a:ea typeface="Segoe UI"/>
                 <a:cs typeface="Segoe UI"/>
               </a:rPr>
-              <a:t>WHAT'S NEXT</a:t>
+              <a:t>The next study measures AI exposure directly</a:t>
             </a:r>
           </a:p>
         </p:txBody>
@@ -5487,6 +5472,27 @@
           <a:lstStyle/>
           <a:p>
             <a:pPr algn="l">
+              <a:spcBef>
+                <a:spcPts val="0"/>
+              </a:spcBef>
+              <a:spcAft>
+                <a:spcPts val="200"/>
+              </a:spcAft>
+            </a:pPr>
+            <a:r>
+              <a:rPr sz="1300" b="1" i="0">
+                <a:solidFill>
+                  <a:srgbClr val="E4F2F2"/>
+                </a:solidFill>
+                <a:latin typeface="Segoe UI"/>
+                <a:ea typeface="Segoe UI"/>
+                <a:cs typeface="Segoe UI"/>
+              </a:rPr>
+              <a:t>TAKE IT HOME</a:t>
+            </a:r>
+          </a:p>
+          <a:p>
+            <a:pPr algn="l">
               <a:lnSpc>
                 <a:spcPct val="100000"/>
               </a:lnSpc>
@@ -5498,7 +5504,7 @@
               </a:spcAft>
             </a:pPr>
             <a:r>
-              <a:rPr sz="3200" b="1" i="0">
+              <a:rPr sz="2700" b="1" i="0">
                 <a:solidFill>
                   <a:srgbClr val="FFFFFF"/>
                 </a:solidFill>
@@ -5506,7 +5512,7 @@
                 <a:ea typeface="Segoe UI"/>
                 <a:cs typeface="Segoe UI"/>
               </a:rPr>
-              <a:t>DIGITAL SWAG</a:t>
+              <a:t>The methods travel; the data do not</a:t>
             </a:r>
           </a:p>
         </p:txBody>
@@ -6159,20 +6165,17 @@
           <a:lstStyle/>
           <a:p>
             <a:pPr algn="l">
-              <a:lnSpc>
-                <a:spcPct val="100000"/>
-              </a:lnSpc>
               <a:spcBef>
                 <a:spcPts val="0"/>
               </a:spcBef>
               <a:spcAft>
-                <a:spcPts val="0"/>
-              </a:spcAft>
-            </a:pPr>
-            <a:r>
-              <a:rPr sz="3000" b="1" i="0">
-                <a:solidFill>
-                  <a:srgbClr val="FFFFFF"/>
+                <a:spcPts val="200"/>
+              </a:spcAft>
+            </a:pPr>
+            <a:r>
+              <a:rPr sz="1300" b="1" i="0">
+                <a:solidFill>
+                  <a:srgbClr val="E4F2F2"/>
                 </a:solidFill>
                 <a:latin typeface="Segoe UI"/>
                 <a:ea typeface="Segoe UI"/>
@@ -6194,7 +6197,7 @@
               </a:spcAft>
             </a:pPr>
             <a:r>
-              <a:rPr sz="3000" b="1" i="0">
+              <a:rPr sz="2700" b="1" i="0">
                 <a:solidFill>
                   <a:srgbClr val="FFFFFF"/>
                 </a:solidFill>
@@ -6516,20 +6519,17 @@
           <a:lstStyle/>
           <a:p>
             <a:pPr algn="l">
-              <a:lnSpc>
-                <a:spcPct val="100000"/>
-              </a:lnSpc>
               <a:spcBef>
                 <a:spcPts val="0"/>
               </a:spcBef>
               <a:spcAft>
-                <a:spcPts val="0"/>
-              </a:spcAft>
-            </a:pPr>
-            <a:r>
-              <a:rPr sz="3000" b="1" i="0">
-                <a:solidFill>
-                  <a:srgbClr val="FFFFFF"/>
+                <a:spcPts val="200"/>
+              </a:spcAft>
+            </a:pPr>
+            <a:r>
+              <a:rPr sz="1300" b="1" i="0">
+                <a:solidFill>
+                  <a:srgbClr val="E4F2F2"/>
                 </a:solidFill>
                 <a:latin typeface="Segoe UI"/>
                 <a:ea typeface="Segoe UI"/>
@@ -6551,7 +6551,7 @@
               </a:spcAft>
             </a:pPr>
             <a:r>
-              <a:rPr sz="3000" b="1" i="0">
+              <a:rPr sz="2700" b="1" i="0">
                 <a:solidFill>
                   <a:srgbClr val="FFFFFF"/>
                 </a:solidFill>
@@ -6873,26 +6873,23 @@
           <a:lstStyle/>
           <a:p>
             <a:pPr algn="l">
-              <a:lnSpc>
-                <a:spcPct val="100000"/>
-              </a:lnSpc>
               <a:spcBef>
                 <a:spcPts val="0"/>
               </a:spcBef>
               <a:spcAft>
-                <a:spcPts val="0"/>
-              </a:spcAft>
-            </a:pPr>
-            <a:r>
-              <a:rPr sz="3000" b="1" i="0">
-                <a:solidFill>
-                  <a:srgbClr val="FFFFFF"/>
-                </a:solidFill>
-                <a:latin typeface="Segoe UI"/>
-                <a:ea typeface="Segoe UI"/>
-                <a:cs typeface="Segoe UI"/>
-              </a:rPr>
-              <a:t>RESULT</a:t>
+                <a:spcPts val="200"/>
+              </a:spcAft>
+            </a:pPr>
+            <a:r>
+              <a:rPr sz="1300" b="1" i="0">
+                <a:solidFill>
+                  <a:srgbClr val="E4F2F2"/>
+                </a:solidFill>
+                <a:latin typeface="Segoe UI"/>
+                <a:ea typeface="Segoe UI"/>
+                <a:cs typeface="Segoe UI"/>
+              </a:rPr>
+              <a:t>EXTRA</a:t>
             </a:r>
           </a:p>
           <a:p>
@@ -6908,7 +6905,7 @@
               </a:spcAft>
             </a:pPr>
             <a:r>
-              <a:rPr sz="3000" b="1" i="0">
+              <a:rPr sz="2000" b="1" i="0">
                 <a:solidFill>
                   <a:srgbClr val="FFFFFF"/>
                 </a:solidFill>
@@ -6916,7 +6913,7 @@
                 <a:ea typeface="Segoe UI"/>
                 <a:cs typeface="Segoe UI"/>
               </a:rPr>
-              <a:t>Competence-coded stories and later strain</a:t>
+              <a:t>Seventeen people grounded meaning in competence; they reported more strain a year later</a:t>
             </a:r>
           </a:p>
         </p:txBody>
@@ -6938,7 +6935,7 @@
         <p:spPr>
           <a:xfrm>
             <a:off x="365760" y="1170432"/>
-            <a:ext cx="9326880" cy="4192238"/>
+            <a:ext cx="9326880" cy="5349240"/>
           </a:xfrm>
           <a:prstGeom prst="rect">
             <a:avLst/>
@@ -6953,8 +6950,8 @@
         </p:nvSpPr>
         <p:spPr>
           <a:xfrm>
-            <a:off x="384048" y="5472398"/>
-            <a:ext cx="9290304" cy="1861089"/>
+            <a:off x="384048" y="6629400"/>
+            <a:ext cx="9290304" cy="704087"/>
           </a:xfrm>
           <a:prstGeom prst="rect">
             <a:avLst/>
@@ -7230,26 +7227,23 @@
           <a:lstStyle/>
           <a:p>
             <a:pPr algn="l">
-              <a:lnSpc>
-                <a:spcPct val="100000"/>
-              </a:lnSpc>
               <a:spcBef>
                 <a:spcPts val="0"/>
               </a:spcBef>
               <a:spcAft>
-                <a:spcPts val="0"/>
-              </a:spcAft>
-            </a:pPr>
-            <a:r>
-              <a:rPr sz="3000" b="1" i="0">
-                <a:solidFill>
-                  <a:srgbClr val="FFFFFF"/>
-                </a:solidFill>
-                <a:latin typeface="Segoe UI"/>
-                <a:ea typeface="Segoe UI"/>
-                <a:cs typeface="Segoe UI"/>
-              </a:rPr>
-              <a:t>RESULT</a:t>
+                <a:spcPts val="200"/>
+              </a:spcAft>
+            </a:pPr>
+            <a:r>
+              <a:rPr sz="1300" b="1" i="0">
+                <a:solidFill>
+                  <a:srgbClr val="E4F2F2"/>
+                </a:solidFill>
+                <a:latin typeface="Segoe UI"/>
+                <a:ea typeface="Segoe UI"/>
+                <a:cs typeface="Segoe UI"/>
+              </a:rPr>
+              <a:t>EXTRA</a:t>
             </a:r>
           </a:p>
           <a:p>
@@ -7265,7 +7259,7 @@
               </a:spcAft>
             </a:pPr>
             <a:r>
-              <a:rPr sz="3000" b="1" i="0">
+              <a:rPr sz="2700" b="1" i="0">
                 <a:solidFill>
                   <a:srgbClr val="FFFFFF"/>
                 </a:solidFill>
@@ -7328,7 +7322,7 @@
               </a:spcAft>
             </a:pPr>
             <a:r>
-              <a:rPr sz="1800" b="0" i="1">
+              <a:rPr sz="1600" b="0" i="1">
                 <a:solidFill>
                   <a:srgbClr val="333333"/>
                 </a:solidFill>
@@ -7587,26 +7581,23 @@
           <a:lstStyle/>
           <a:p>
             <a:pPr algn="l">
-              <a:lnSpc>
-                <a:spcPct val="100000"/>
-              </a:lnSpc>
               <a:spcBef>
                 <a:spcPts val="0"/>
               </a:spcBef>
               <a:spcAft>
-                <a:spcPts val="0"/>
-              </a:spcAft>
-            </a:pPr>
-            <a:r>
-              <a:rPr sz="3000" b="1" i="0">
-                <a:solidFill>
-                  <a:srgbClr val="FFFFFF"/>
-                </a:solidFill>
-                <a:latin typeface="Segoe UI"/>
-                <a:ea typeface="Segoe UI"/>
-                <a:cs typeface="Segoe UI"/>
-              </a:rPr>
-              <a:t>RESULT</a:t>
+                <a:spcPts val="200"/>
+              </a:spcAft>
+            </a:pPr>
+            <a:r>
+              <a:rPr sz="1300" b="1" i="0">
+                <a:solidFill>
+                  <a:srgbClr val="E4F2F2"/>
+                </a:solidFill>
+                <a:latin typeface="Segoe UI"/>
+                <a:ea typeface="Segoe UI"/>
+                <a:cs typeface="Segoe UI"/>
+              </a:rPr>
+              <a:t>EXTRA</a:t>
             </a:r>
           </a:p>
           <a:p>
@@ -7622,7 +7613,7 @@
               </a:spcAft>
             </a:pPr>
             <a:r>
-              <a:rPr sz="3000" b="1" i="0">
+              <a:rPr sz="2400" b="1" i="0">
                 <a:solidFill>
                   <a:srgbClr val="FFFFFF"/>
                 </a:solidFill>
@@ -7630,7 +7621,7 @@
                 <a:ea typeface="Segoe UI"/>
                 <a:cs typeface="Segoe UI"/>
               </a:rPr>
-              <a:t>Forum meaning events by facet, polarity, and period</a:t>
+              <a:t>Frustrated control was the only forum cell that grew</a:t>
             </a:r>
           </a:p>
         </p:txBody>
@@ -7944,6 +7935,27 @@
           <a:lstStyle/>
           <a:p>
             <a:pPr algn="l">
+              <a:spcBef>
+                <a:spcPts val="0"/>
+              </a:spcBef>
+              <a:spcAft>
+                <a:spcPts val="200"/>
+              </a:spcAft>
+            </a:pPr>
+            <a:r>
+              <a:rPr sz="1300" b="1" i="0">
+                <a:solidFill>
+                  <a:srgbClr val="E4F2F2"/>
+                </a:solidFill>
+                <a:latin typeface="Segoe UI"/>
+                <a:ea typeface="Segoe UI"/>
+                <a:cs typeface="Segoe UI"/>
+              </a:rPr>
+              <a:t>AUTHORS</a:t>
+            </a:r>
+          </a:p>
+          <a:p>
+            <a:pPr algn="l">
               <a:lnSpc>
                 <a:spcPct val="100000"/>
               </a:lnSpc>
@@ -7955,7 +7967,7 @@
               </a:spcAft>
             </a:pPr>
             <a:r>
-              <a:rPr sz="3200" b="1" i="0">
+              <a:rPr sz="2700" b="1" i="0">
                 <a:solidFill>
                   <a:srgbClr val="FFFFFF"/>
                 </a:solidFill>
@@ -7963,7 +7975,7 @@
                 <a:ea typeface="Segoe UI"/>
                 <a:cs typeface="Segoe UI"/>
               </a:rPr>
-              <a:t>AUTHOR  ·  THESIS</a:t>
+              <a:t>Efficiency can be paid for in strain and exit</a:t>
             </a:r>
           </a:p>
         </p:txBody>
@@ -8496,6 +8508,27 @@
           <a:lstStyle/>
           <a:p>
             <a:pPr algn="l">
+              <a:spcBef>
+                <a:spcPts val="0"/>
+              </a:spcBef>
+              <a:spcAft>
+                <a:spcPts val="200"/>
+              </a:spcAft>
+            </a:pPr>
+            <a:r>
+              <a:rPr sz="1300" b="1" i="0">
+                <a:solidFill>
+                  <a:srgbClr val="E4F2F2"/>
+                </a:solidFill>
+                <a:latin typeface="Segoe UI"/>
+                <a:ea typeface="Segoe UI"/>
+                <a:cs typeface="Segoe UI"/>
+              </a:rPr>
+              <a:t>WHY NOW</a:t>
+            </a:r>
+          </a:p>
+          <a:p>
+            <a:pPr algn="l">
               <a:lnSpc>
                 <a:spcPct val="100000"/>
               </a:lnSpc>
@@ -8507,7 +8540,7 @@
               </a:spcAft>
             </a:pPr>
             <a:r>
-              <a:rPr sz="3200" b="1" i="0">
+              <a:rPr sz="2400" b="1" i="0">
                 <a:solidFill>
                   <a:srgbClr val="FFFFFF"/>
                 </a:solidFill>
@@ -8515,7 +8548,7 @@
                 <a:ea typeface="Segoe UI"/>
                 <a:cs typeface="Segoe UI"/>
               </a:rPr>
-              <a:t>WHY THIS MATTERS NOW</a:t>
+              <a:t>People analytics is about to inherit meaning at scale</a:t>
             </a:r>
           </a:p>
         </p:txBody>
@@ -8841,26 +8874,23 @@
           <a:lstStyle/>
           <a:p>
             <a:pPr algn="l">
-              <a:lnSpc>
-                <a:spcPct val="100000"/>
-              </a:lnSpc>
               <a:spcBef>
                 <a:spcPts val="0"/>
               </a:spcBef>
               <a:spcAft>
-                <a:spcPts val="0"/>
-              </a:spcAft>
-            </a:pPr>
-            <a:r>
-              <a:rPr sz="3000" b="1" i="0">
-                <a:solidFill>
-                  <a:srgbClr val="FFFFFF"/>
-                </a:solidFill>
-                <a:latin typeface="Segoe UI"/>
-                <a:ea typeface="Segoe UI"/>
-                <a:cs typeface="Segoe UI"/>
-              </a:rPr>
-              <a:t>SCAN FOR LATEST RESULTS</a:t>
+                <a:spcPts val="200"/>
+              </a:spcAft>
+            </a:pPr>
+            <a:r>
+              <a:rPr sz="1300" b="1" i="0">
+                <a:solidFill>
+                  <a:srgbClr val="E4F2F2"/>
+                </a:solidFill>
+                <a:latin typeface="Segoe UI"/>
+                <a:ea typeface="Segoe UI"/>
+                <a:cs typeface="Segoe UI"/>
+              </a:rPr>
+              <a:t>SCAN</a:t>
             </a:r>
           </a:p>
           <a:p>
@@ -8876,7 +8906,7 @@
               </a:spcAft>
             </a:pPr>
             <a:r>
-              <a:rPr sz="3000" b="1" i="0">
+              <a:rPr sz="2700" b="1" i="0">
                 <a:solidFill>
                   <a:srgbClr val="FFFFFF"/>
                 </a:solidFill>
@@ -8884,7 +8914,7 @@
                 <a:ea typeface="Segoe UI"/>
                 <a:cs typeface="Segoe UI"/>
               </a:rPr>
-              <a:t>&amp; RESOURCES</a:t>
+              <a:t>Everything here, updated through the week</a:t>
             </a:r>
           </a:p>
         </p:txBody>
@@ -9239,6 +9269,27 @@
           <a:lstStyle/>
           <a:p>
             <a:pPr algn="l">
+              <a:spcBef>
+                <a:spcPts val="0"/>
+              </a:spcBef>
+              <a:spcAft>
+                <a:spcPts val="200"/>
+              </a:spcAft>
+            </a:pPr>
+            <a:r>
+              <a:rPr sz="1300" b="1" i="0">
+                <a:solidFill>
+                  <a:srgbClr val="E4F2F2"/>
+                </a:solidFill>
+                <a:latin typeface="Segoe UI"/>
+                <a:ea typeface="Segoe UI"/>
+                <a:cs typeface="Segoe UI"/>
+              </a:rPr>
+              <a:t>FRAMEWORK</a:t>
+            </a:r>
+          </a:p>
+          <a:p>
+            <a:pPr algn="l">
               <a:lnSpc>
                 <a:spcPct val="100000"/>
               </a:lnSpc>
@@ -9250,7 +9301,7 @@
               </a:spcAft>
             </a:pPr>
             <a:r>
-              <a:rPr sz="3200" b="1" i="0">
+              <a:rPr sz="2700" b="1" i="0">
                 <a:solidFill>
                   <a:srgbClr val="FFFFFF"/>
                 </a:solidFill>
@@ -9258,7 +9309,7 @@
                 <a:ea typeface="Segoe UI"/>
                 <a:cs typeface="Segoe UI"/>
               </a:rPr>
-              <a:t>THE FRAMEWORK</a:t>
+              <a:t>Meaning runs on four pathways, not one score</a:t>
             </a:r>
           </a:p>
         </p:txBody>
@@ -9572,6 +9623,27 @@
           <a:lstStyle/>
           <a:p>
             <a:pPr algn="l">
+              <a:spcBef>
+                <a:spcPts val="0"/>
+              </a:spcBef>
+              <a:spcAft>
+                <a:spcPts val="200"/>
+              </a:spcAft>
+            </a:pPr>
+            <a:r>
+              <a:rPr sz="1300" b="1" i="0">
+                <a:solidFill>
+                  <a:srgbClr val="E4F2F2"/>
+                </a:solidFill>
+                <a:latin typeface="Segoe UI"/>
+                <a:ea typeface="Segoe UI"/>
+                <a:cs typeface="Segoe UI"/>
+              </a:rPr>
+              <a:t>QUESTIONS</a:t>
+            </a:r>
+          </a:p>
+          <a:p>
+            <a:pPr algn="l">
               <a:lnSpc>
                 <a:spcPct val="100000"/>
               </a:lnSpc>
@@ -9583,7 +9655,7 @@
               </a:spcAft>
             </a:pPr>
             <a:r>
-              <a:rPr sz="3200" b="1" i="0">
+              <a:rPr sz="2700" b="1" i="0">
                 <a:solidFill>
                   <a:srgbClr val="FFFFFF"/>
                 </a:solidFill>
@@ -9591,7 +9663,7 @@
                 <a:ea typeface="Segoe UI"/>
                 <a:cs typeface="Segoe UI"/>
               </a:rPr>
-              <a:t>OPEN QUESTIONS WE TEST</a:t>
+              <a:t>Three questions the literature left open</a:t>
             </a:r>
           </a:p>
         </p:txBody>
@@ -9917,6 +9989,27 @@
           <a:lstStyle/>
           <a:p>
             <a:pPr algn="l">
+              <a:spcBef>
+                <a:spcPts val="0"/>
+              </a:spcBef>
+              <a:spcAft>
+                <a:spcPts val="200"/>
+              </a:spcAft>
+            </a:pPr>
+            <a:r>
+              <a:rPr sz="1300" b="1" i="0">
+                <a:solidFill>
+                  <a:srgbClr val="E4F2F2"/>
+                </a:solidFill>
+                <a:latin typeface="Segoe UI"/>
+                <a:ea typeface="Segoe UI"/>
+                <a:cs typeface="Segoe UI"/>
+              </a:rPr>
+              <a:t>DESIGN</a:t>
+            </a:r>
+          </a:p>
+          <a:p>
+            <a:pPr algn="l">
               <a:lnSpc>
                 <a:spcPct val="100000"/>
               </a:lnSpc>
@@ -9928,7 +10021,7 @@
               </a:spcAft>
             </a:pPr>
             <a:r>
-              <a:rPr sz="3200" b="1" i="0">
+              <a:rPr sz="2700" b="1" i="0">
                 <a:solidFill>
                   <a:srgbClr val="FFFFFF"/>
                 </a:solidFill>
@@ -9936,7 +10029,7 @@
                 <a:ea typeface="Segoe UI"/>
                 <a:cs typeface="Segoe UI"/>
               </a:rPr>
-              <a:t>STUDY DESIGN</a:t>
+              <a:t>Two waves, two coders, one sealed holdout</a:t>
             </a:r>
           </a:p>
         </p:txBody>
@@ -10250,20 +10343,17 @@
           <a:lstStyle/>
           <a:p>
             <a:pPr algn="l">
-              <a:lnSpc>
-                <a:spcPct val="100000"/>
-              </a:lnSpc>
               <a:spcBef>
                 <a:spcPts val="0"/>
               </a:spcBef>
               <a:spcAft>
-                <a:spcPts val="0"/>
-              </a:spcAft>
-            </a:pPr>
-            <a:r>
-              <a:rPr sz="3000" b="1" i="0">
-                <a:solidFill>
-                  <a:srgbClr val="FFFFFF"/>
+                <a:spcPts val="200"/>
+              </a:spcAft>
+            </a:pPr>
+            <a:r>
+              <a:rPr sz="1300" b="1" i="0">
+                <a:solidFill>
+                  <a:srgbClr val="E4F2F2"/>
                 </a:solidFill>
                 <a:latin typeface="Segoe UI"/>
                 <a:ea typeface="Segoe UI"/>
@@ -10285,7 +10375,7 @@
               </a:spcAft>
             </a:pPr>
             <a:r>
-              <a:rPr sz="3000" b="1" i="0">
+              <a:rPr sz="2700" b="1" i="0">
                 <a:solidFill>
                   <a:srgbClr val="FFFFFF"/>
                 </a:solidFill>
@@ -10607,6 +10697,27 @@
           <a:lstStyle/>
           <a:p>
             <a:pPr algn="l">
+              <a:spcBef>
+                <a:spcPts val="0"/>
+              </a:spcBef>
+              <a:spcAft>
+                <a:spcPts val="200"/>
+              </a:spcAft>
+            </a:pPr>
+            <a:r>
+              <a:rPr sz="1300" b="1" i="0">
+                <a:solidFill>
+                  <a:srgbClr val="E4F2F2"/>
+                </a:solidFill>
+                <a:latin typeface="Segoe UI"/>
+                <a:ea typeface="Segoe UI"/>
+                <a:cs typeface="Segoe UI"/>
+              </a:rPr>
+              <a:t>PRACTICE</a:t>
+            </a:r>
+          </a:p>
+          <a:p>
+            <a:pPr algn="l">
               <a:lnSpc>
                 <a:spcPct val="100000"/>
               </a:lnSpc>
@@ -10618,7 +10729,7 @@
               </a:spcAft>
             </a:pPr>
             <a:r>
-              <a:rPr sz="3200" b="1" i="0">
+              <a:rPr sz="2400" b="1" i="0">
                 <a:solidFill>
                   <a:srgbClr val="FFFFFF"/>
                 </a:solidFill>
@@ -10626,7 +10737,7 @@
                 <a:ea typeface="Segoe UI"/>
                 <a:cs typeface="Segoe UI"/>
               </a:rPr>
-              <a:t>WHAT FINDING 1 MEANS FOR PRACTICE</a:t>
+              <a:t>Ask which ceiling the vendor beat, on which dimension</a:t>
             </a:r>
           </a:p>
         </p:txBody>

</xml_diff>

<commit_message>
lec-2026: deck v5 leads with findings (F2 protocol, F3 competence); Finding 4/5 tiles use poster-mode renders; 18 slides
</commit_message>
<xml_diff>
--- a/lec-2026/assets/Monnot_Poster_v5.pptx
+++ b/lec-2026/assets/Monnot_Poster_v5.pptx
@@ -23,7 +23,6 @@
     <p:sldId id="271" r:id="rId22"/>
     <p:sldId id="272" r:id="rId23"/>
     <p:sldId id="273" r:id="rId24"/>
-    <p:sldId id="274" r:id="rId25"/>
   </p:sldIdLst>
   <p:sldSz cx="10058400" cy="7772400" type="screen4x3"/>
   <p:notesSz cx="6858000" cy="9144000"/>
@@ -3676,7 +3675,7 @@
               </a:spcAft>
             </a:pPr>
             <a:r>
-              <a:rPr sz="2700" b="1" i="0">
+              <a:rPr sz="2200" b="1" i="0">
                 <a:solidFill>
                   <a:srgbClr val="FFFFFF"/>
                 </a:solidFill>
@@ -3684,7 +3683,7 @@
                 <a:ea typeface="Segoe UI"/>
                 <a:cs typeface="Segoe UI"/>
               </a:rPr>
-              <a:t>No engineered prompt met the human bar</a:t>
+              <a:t>The acceptance bars caught six prompts that looked precise</a:t>
             </a:r>
           </a:p>
         </p:txBody>
@@ -3747,7 +3746,7 @@
                 <a:ea typeface="Segoe UI"/>
                 <a:cs typeface="Segoe UI"/>
               </a:rPr>
-              <a:t>Six frozen prompts, scored once on the 55-case development set; each also produced false positives on cells both humans coded absent, which disqualified it. Communion and Self had no bar: human agreement was too low to validate against. A later 65-case look at the two best prompts landed in the same place (Agency .81; Others .746–.770); 128 test cases stay sealed. Study 1 runs on the human codes.</a:t>
+              <a:t>Six frozen prompts, scored once on the 55-case development set, reached agency .750–.798 against a .910 bar and each over-called meaning on cells both humans coded absent, so none was admitted. A later 65-case out-of-sample look at the two best landed in the same range (Agency .81; Others .746–.770); 128 test cases stay sealed for the next instrument. Dimension-specific bars, a sealed holdout, and a false-positive disqualifier are the reusable deliverable.</a:t>
             </a:r>
           </a:p>
         </p:txBody>
@@ -4030,7 +4029,7 @@
               </a:spcAft>
             </a:pPr>
             <a:r>
-              <a:rPr sz="2700" b="1" i="0">
+              <a:rPr sz="2200" b="1" i="0">
                 <a:solidFill>
                   <a:srgbClr val="FFFFFF"/>
                 </a:solidFill>
@@ -4038,14 +4037,14 @@
                 <a:ea typeface="Segoe UI"/>
                 <a:cs typeface="Segoe UI"/>
               </a:rPr>
-              <a:t>Registered next-year estimates came in near zero</a:t>
+              <a:t>Meaning narrated as competence reached next year’s strain</a:t>
             </a:r>
           </a:p>
         </p:txBody>
       </p:sp>
       <p:pic>
         <p:nvPicPr>
-          <p:cNvPr id="5" name="Picture 4" descr="fig_confirmatory_forest.png"/>
+          <p:cNvPr id="5" name="Picture 4" descr="fig_competence.png"/>
           <p:cNvPicPr>
             <a:picLocks noChangeAspect="1"/>
           </p:cNvPicPr>
@@ -4060,7 +4059,7 @@
         <p:spPr>
           <a:xfrm>
             <a:off x="365760" y="1170432"/>
-            <a:ext cx="9326880" cy="4472871"/>
+            <a:ext cx="9326880" cy="5349240"/>
           </a:xfrm>
           <a:prstGeom prst="rect">
             <a:avLst/>
@@ -4075,8 +4074,8 @@
         </p:nvSpPr>
         <p:spPr>
           <a:xfrm>
-            <a:off x="384048" y="5753031"/>
-            <a:ext cx="9290304" cy="1580456"/>
+            <a:off x="384048" y="6629400"/>
+            <a:ext cx="9290304" cy="704087"/>
           </a:xfrm>
           <a:prstGeom prst="rect">
             <a:avLst/>
@@ -4093,7 +4092,7 @@
               </a:spcAft>
             </a:pPr>
             <a:r>
-              <a:rPr sz="1800" b="0" i="1">
+              <a:rPr sz="1300" b="0" i="1">
                 <a:solidFill>
                   <a:srgbClr val="333333"/>
                 </a:solidFill>
@@ -4101,7 +4100,7 @@
                 <a:ea typeface="Segoe UI"/>
                 <a:cs typeface="Segoe UI"/>
               </a:rPr>
-              <a:t>Others, agency, and self were not associated with T2 meaning, exhaustion, or turnover; three of five coefficients equivalent to zero at |β| = .30. Joint block ΔR² = .012. BF01 = 481.5 on next-year meaningfulness. The same codes tracked concurrent WAMI.</a:t>
+              <a:t>Competence or mastery in the Time 1 story went with higher Time 2 turnover intentions (b = 1.40) and exhaustion (b = 0.95); 17 of 140 matched cases, holding a joint Time 1 survey battery. The pre-specified dimension paths sat near zero, which singles this code out. Exploratory; the lead for the next designed study.</a:t>
             </a:r>
           </a:p>
         </p:txBody>
@@ -5793,7 +5792,7 @@
                 <a:ea typeface="Segoe UI"/>
                 <a:cs typeface="Segoe UI"/>
               </a:rPr>
-              <a:t>Locked split, pre-registered bars, and run provenance (model pin, prompt hash, git SHA).</a:t>
+              <a:t>Locked split, pre-specified bars, and run provenance (model pin, prompt hash, git SHA).</a:t>
             </a:r>
           </a:p>
         </p:txBody>
@@ -6227,7 +6226,7 @@
         <p:spPr>
           <a:xfrm>
             <a:off x="365760" y="1170432"/>
-            <a:ext cx="9326880" cy="3750130"/>
+            <a:ext cx="9326880" cy="4732288"/>
           </a:xfrm>
           <a:prstGeom prst="rect">
             <a:avLst/>
@@ -6242,8 +6241,8 @@
         </p:nvSpPr>
         <p:spPr>
           <a:xfrm>
-            <a:off x="384048" y="5030290"/>
-            <a:ext cx="9290304" cy="2303197"/>
+            <a:off x="384048" y="6012448"/>
+            <a:ext cx="9290304" cy="1321039"/>
           </a:xfrm>
           <a:prstGeom prst="rect">
             <a:avLst/>
@@ -6268,7 +6267,7 @@
                 <a:ea typeface="Segoe UI"/>
                 <a:cs typeface="Segoe UI"/>
               </a:rPr>
-              <a:t>7,709 allnurses posts, capture years 2016–2026, one-model event codes. Seven named-AI events, none after 2021. Ratios, metrics, charting: one post in twenty, flat. Lack-of-control flag +4 points (template-change caveat). Not validated on forum text.</a:t>
+              <a:t>7,709 allnurses posts, capture years 2016–2026, one-model event codes. Seven named-AI events, none after 2021. Ratios, metrics, charting: one post in twenty across the decade. Lack-of-control flag +4 points (template-change caveat). One-model codes.</a:t>
             </a:r>
           </a:p>
         </p:txBody>
@@ -6581,7 +6580,7 @@
         <p:spPr>
           <a:xfrm>
             <a:off x="365760" y="1170432"/>
-            <a:ext cx="9326880" cy="2989676"/>
+            <a:ext cx="9326880" cy="4755003"/>
           </a:xfrm>
           <a:prstGeom prst="rect">
             <a:avLst/>
@@ -6596,8 +6595,8 @@
         </p:nvSpPr>
         <p:spPr>
           <a:xfrm>
-            <a:off x="384048" y="4269836"/>
-            <a:ext cx="9290304" cy="3063652"/>
+            <a:off x="384048" y="6035163"/>
+            <a:ext cx="9290304" cy="1298324"/>
           </a:xfrm>
           <a:prstGeom prst="rect">
             <a:avLst/>
@@ -6905,7 +6904,7 @@
               </a:spcAft>
             </a:pPr>
             <a:r>
-              <a:rPr sz="2000" b="1" i="0">
+              <a:rPr sz="2200" b="1" i="0">
                 <a:solidFill>
                   <a:srgbClr val="FFFFFF"/>
                 </a:solidFill>
@@ -6913,14 +6912,14 @@
                 <a:ea typeface="Segoe UI"/>
                 <a:cs typeface="Segoe UI"/>
               </a:rPr>
-              <a:t>Seventeen people grounded meaning in competence; they reported more strain a year later</a:t>
+              <a:t>Concurrent meaning rises with code density, then levels</a:t>
             </a:r>
           </a:p>
         </p:txBody>
       </p:sp>
       <p:pic>
         <p:nvPicPr>
-          <p:cNvPr id="5" name="Picture 4" descr="fig_competence.png"/>
+          <p:cNvPr id="5" name="Picture 4" descr="fig_density_wami_quadratic.png"/>
           <p:cNvPicPr>
             <a:picLocks noChangeAspect="1"/>
           </p:cNvPicPr>
@@ -6934,8 +6933,8 @@
         </p:blipFill>
         <p:spPr>
           <a:xfrm>
-            <a:off x="365760" y="1170432"/>
-            <a:ext cx="9326880" cy="5349240"/>
+            <a:off x="1261040" y="1170432"/>
+            <a:ext cx="7536319" cy="5440680"/>
           </a:xfrm>
           <a:prstGeom prst="rect">
             <a:avLst/>
@@ -6950,8 +6949,8 @@
         </p:nvSpPr>
         <p:spPr>
           <a:xfrm>
-            <a:off x="384048" y="6629400"/>
-            <a:ext cx="9290304" cy="704087"/>
+            <a:off x="384048" y="6720840"/>
+            <a:ext cx="9290304" cy="612647"/>
           </a:xfrm>
           <a:prstGeom prst="rect">
             <a:avLst/>
@@ -6968,7 +6967,7 @@
               </a:spcAft>
             </a:pPr>
             <a:r>
-              <a:rPr sz="1800" b="0" i="1">
+              <a:rPr sz="1400" b="0" i="1">
                 <a:solidFill>
                   <a:srgbClr val="333333"/>
                 </a:solidFill>
@@ -6976,7 +6975,7 @@
                 <a:ea typeface="Segoe UI"/>
                 <a:cs typeface="Segoe UI"/>
               </a:rPr>
-              <a:t>Exploratory. T1 competence/mastery codes, higher T2 turnover (b = 1.40) and exhaustion (b = 0.95). Seventeen present cases of 140. Not a product finding.</a:t>
+              <a:t>Pathway density tracks Time 1 WAMI (others-directed r = .24; agency r = .20; contribution r = .23). Felt meaning rises from zero to two narrated pathways and flattens after; exploratory quadratic.</a:t>
             </a:r>
           </a:p>
         </p:txBody>
@@ -7259,7 +7258,7 @@
               </a:spcAft>
             </a:pPr>
             <a:r>
-              <a:rPr sz="2700" b="1" i="0">
+              <a:rPr sz="2400" b="1" i="0">
                 <a:solidFill>
                   <a:srgbClr val="FFFFFF"/>
                 </a:solidFill>
@@ -7267,14 +7266,14 @@
                 <a:ea typeface="Segoe UI"/>
                 <a:cs typeface="Segoe UI"/>
               </a:rPr>
-              <a:t>Concurrent meaning tracks code density</a:t>
+              <a:t>Frustrated control was the only forum cell that grew</a:t>
             </a:r>
           </a:p>
         </p:txBody>
       </p:sp>
       <p:pic>
         <p:nvPicPr>
-          <p:cNvPr id="5" name="Picture 4" descr="fig_density_wami_quadratic.png"/>
+          <p:cNvPr id="5" name="Picture 4" descr="Study2_fig2_facets.png"/>
           <p:cNvPicPr>
             <a:picLocks noChangeAspect="1"/>
           </p:cNvPicPr>
@@ -7288,8 +7287,8 @@
         </p:blipFill>
         <p:spPr>
           <a:xfrm>
-            <a:off x="1261040" y="1170432"/>
-            <a:ext cx="7536319" cy="5440680"/>
+            <a:off x="365760" y="1170432"/>
+            <a:ext cx="9326880" cy="4235471"/>
           </a:xfrm>
           <a:prstGeom prst="rect">
             <a:avLst/>
@@ -7304,8 +7303,8 @@
         </p:nvSpPr>
         <p:spPr>
           <a:xfrm>
-            <a:off x="384048" y="6720840"/>
-            <a:ext cx="9290304" cy="612647"/>
+            <a:off x="384048" y="5515631"/>
+            <a:ext cx="9290304" cy="1817856"/>
           </a:xfrm>
           <a:prstGeom prst="rect">
             <a:avLst/>
@@ -7322,7 +7321,7 @@
               </a:spcAft>
             </a:pPr>
             <a:r>
-              <a:rPr sz="1600" b="0" i="1">
+              <a:rPr sz="1800" b="0" i="1">
                 <a:solidFill>
                   <a:srgbClr val="333333"/>
                 </a:solidFill>
@@ -7330,7 +7329,7 @@
                 <a:ea typeface="Segoe UI"/>
                 <a:cs typeface="Segoe UI"/>
               </a:rPr>
-              <a:t>The codebook was not empty. Pathway density tracks T1 WAMI. Quadratic flattening is exploratory; not the registered T2 block.</a:t>
+              <a:t>Events per 100 posts, one-model codes. Competence most enacted; Control/Autonomy most frustrated and the only cell that grew. Communion spread across five thin, mostly enacted rows. One-model codes; capture year is the time axis.</a:t>
             </a:r>
           </a:p>
         </p:txBody>
@@ -7452,360 +7451,6 @@
                 <a:cs typeface="Segoe UI"/>
               </a:rPr>
               <a:t>X2</a:t>
-            </a:r>
-          </a:p>
-        </p:txBody>
-      </p:sp>
-    </p:spTree>
-  </p:cSld>
-  <p:clrMapOvr>
-    <a:masterClrMapping/>
-  </p:clrMapOvr>
-</p:sld>
-</file>
-
-<file path=ppt/slides/slide19.xml><?xml version="1.0" encoding="utf-8"?>
-<p:sld xmlns:a="http://schemas.openxmlformats.org/drawingml/2006/main" xmlns:p="http://schemas.openxmlformats.org/presentationml/2006/main" xmlns:r="http://schemas.openxmlformats.org/officeDocument/2006/relationships">
-  <p:cSld>
-    <p:spTree>
-      <p:nvGrpSpPr>
-        <p:cNvPr id="1" name=""/>
-        <p:cNvGrpSpPr/>
-        <p:nvPr/>
-      </p:nvGrpSpPr>
-      <p:grpSpPr/>
-      <p:sp>
-        <p:nvSpPr>
-          <p:cNvPr id="2" name="Rectangle 1"/>
-          <p:cNvSpPr/>
-          <p:nvPr/>
-        </p:nvSpPr>
-        <p:spPr>
-          <a:xfrm>
-            <a:off x="0" y="0"/>
-            <a:ext cx="10058400" cy="1024128"/>
-          </a:xfrm>
-          <a:prstGeom prst="rect">
-            <a:avLst/>
-          </a:prstGeom>
-          <a:solidFill>
-            <a:srgbClr val="1F3A5F"/>
-          </a:solidFill>
-          <a:ln>
-            <a:noFill/>
-          </a:ln>
-        </p:spPr>
-        <p:style>
-          <a:lnRef idx="1">
-            <a:schemeClr val="accent1"/>
-          </a:lnRef>
-          <a:fillRef idx="3">
-            <a:schemeClr val="accent1"/>
-          </a:fillRef>
-          <a:effectRef idx="2">
-            <a:schemeClr val="accent1"/>
-          </a:effectRef>
-          <a:fontRef idx="minor">
-            <a:schemeClr val="lt1"/>
-          </a:fontRef>
-        </p:style>
-        <p:txBody>
-          <a:bodyPr rtlCol="0" anchor="ctr"/>
-          <a:lstStyle/>
-          <a:p>
-            <a:pPr algn="ctr"/>
-          </a:p>
-        </p:txBody>
-      </p:sp>
-      <p:sp>
-        <p:nvSpPr>
-          <p:cNvPr id="3" name="Rectangle 2"/>
-          <p:cNvSpPr/>
-          <p:nvPr/>
-        </p:nvSpPr>
-        <p:spPr>
-          <a:xfrm>
-            <a:off x="0" y="1024128"/>
-            <a:ext cx="10058400" cy="54864"/>
-          </a:xfrm>
-          <a:prstGeom prst="rect">
-            <a:avLst/>
-          </a:prstGeom>
-          <a:solidFill>
-            <a:srgbClr val="2E8B8B"/>
-          </a:solidFill>
-          <a:ln>
-            <a:noFill/>
-          </a:ln>
-        </p:spPr>
-        <p:style>
-          <a:lnRef idx="1">
-            <a:schemeClr val="accent1"/>
-          </a:lnRef>
-          <a:fillRef idx="3">
-            <a:schemeClr val="accent1"/>
-          </a:fillRef>
-          <a:effectRef idx="2">
-            <a:schemeClr val="accent1"/>
-          </a:effectRef>
-          <a:fontRef idx="minor">
-            <a:schemeClr val="lt1"/>
-          </a:fontRef>
-        </p:style>
-        <p:txBody>
-          <a:bodyPr rtlCol="0" anchor="ctr"/>
-          <a:lstStyle/>
-          <a:p>
-            <a:pPr algn="ctr"/>
-          </a:p>
-        </p:txBody>
-      </p:sp>
-      <p:sp>
-        <p:nvSpPr>
-          <p:cNvPr id="4" name="TextBox 3"/>
-          <p:cNvSpPr txBox="1"/>
-          <p:nvPr/>
-        </p:nvSpPr>
-        <p:spPr>
-          <a:xfrm>
-            <a:off x="347472" y="73152"/>
-            <a:ext cx="9363456" cy="896112"/>
-          </a:xfrm>
-          <a:prstGeom prst="rect">
-            <a:avLst/>
-          </a:prstGeom>
-          <a:noFill/>
-        </p:spPr>
-        <p:txBody>
-          <a:bodyPr wrap="square" lIns="36576" rIns="36576" tIns="18288" bIns="18288" anchor="ctr"/>
-          <a:lstStyle/>
-          <a:p>
-            <a:pPr algn="l">
-              <a:spcBef>
-                <a:spcPts val="0"/>
-              </a:spcBef>
-              <a:spcAft>
-                <a:spcPts val="200"/>
-              </a:spcAft>
-            </a:pPr>
-            <a:r>
-              <a:rPr sz="1300" b="1" i="0">
-                <a:solidFill>
-                  <a:srgbClr val="E4F2F2"/>
-                </a:solidFill>
-                <a:latin typeface="Segoe UI"/>
-                <a:ea typeface="Segoe UI"/>
-                <a:cs typeface="Segoe UI"/>
-              </a:rPr>
-              <a:t>EXTRA</a:t>
-            </a:r>
-          </a:p>
-          <a:p>
-            <a:pPr algn="l">
-              <a:lnSpc>
-                <a:spcPct val="100000"/>
-              </a:lnSpc>
-              <a:spcBef>
-                <a:spcPts val="0"/>
-              </a:spcBef>
-              <a:spcAft>
-                <a:spcPts val="0"/>
-              </a:spcAft>
-            </a:pPr>
-            <a:r>
-              <a:rPr sz="2400" b="1" i="0">
-                <a:solidFill>
-                  <a:srgbClr val="FFFFFF"/>
-                </a:solidFill>
-                <a:latin typeface="Segoe UI"/>
-                <a:ea typeface="Segoe UI"/>
-                <a:cs typeface="Segoe UI"/>
-              </a:rPr>
-              <a:t>Frustrated control was the only forum cell that grew</a:t>
-            </a:r>
-          </a:p>
-        </p:txBody>
-      </p:sp>
-      <p:pic>
-        <p:nvPicPr>
-          <p:cNvPr id="5" name="Picture 4" descr="Study2_fig2_facets.png"/>
-          <p:cNvPicPr>
-            <a:picLocks noChangeAspect="1"/>
-          </p:cNvPicPr>
-          <p:nvPr/>
-        </p:nvPicPr>
-        <p:blipFill>
-          <a:blip r:embed="rId2"/>
-          <a:stretch>
-            <a:fillRect/>
-          </a:stretch>
-        </p:blipFill>
-        <p:spPr>
-          <a:xfrm>
-            <a:off x="365760" y="1170432"/>
-            <a:ext cx="9326880" cy="4029026"/>
-          </a:xfrm>
-          <a:prstGeom prst="rect">
-            <a:avLst/>
-          </a:prstGeom>
-        </p:spPr>
-      </p:pic>
-      <p:sp>
-        <p:nvSpPr>
-          <p:cNvPr id="6" name="TextBox 5"/>
-          <p:cNvSpPr txBox="1"/>
-          <p:nvPr/>
-        </p:nvSpPr>
-        <p:spPr>
-          <a:xfrm>
-            <a:off x="384048" y="5309186"/>
-            <a:ext cx="9290304" cy="2024301"/>
-          </a:xfrm>
-          <a:prstGeom prst="rect">
-            <a:avLst/>
-          </a:prstGeom>
-          <a:noFill/>
-        </p:spPr>
-        <p:txBody>
-          <a:bodyPr wrap="square" lIns="36576" rIns="36576" tIns="18288" bIns="18288" anchor="t"/>
-          <a:lstStyle/>
-          <a:p>
-            <a:pPr algn="l">
-              <a:spcAft>
-                <a:spcPts val="0"/>
-              </a:spcAft>
-            </a:pPr>
-            <a:r>
-              <a:rPr sz="1800" b="0" i="1">
-                <a:solidFill>
-                  <a:srgbClr val="333333"/>
-                </a:solidFill>
-                <a:latin typeface="Segoe UI"/>
-                <a:ea typeface="Segoe UI"/>
-                <a:cs typeface="Segoe UI"/>
-              </a:rPr>
-              <a:t>Events per 100 posts, one-model codes. Competence most enacted; Control/Autonomy most frustrated and the only cell that grew. Communion spread across five thin, mostly enacted rows. Not validated on forum text; capture year, not posted-at.</a:t>
-            </a:r>
-          </a:p>
-        </p:txBody>
-      </p:sp>
-      <p:sp>
-        <p:nvSpPr>
-          <p:cNvPr id="7" name="Rectangle 6"/>
-          <p:cNvSpPr/>
-          <p:nvPr/>
-        </p:nvSpPr>
-        <p:spPr>
-          <a:xfrm>
-            <a:off x="347472" y="7424927"/>
-            <a:ext cx="9363456" cy="13716"/>
-          </a:xfrm>
-          <a:prstGeom prst="rect">
-            <a:avLst/>
-          </a:prstGeom>
-          <a:solidFill>
-            <a:srgbClr val="1F3A5F"/>
-          </a:solidFill>
-          <a:ln>
-            <a:noFill/>
-          </a:ln>
-        </p:spPr>
-        <p:style>
-          <a:lnRef idx="1">
-            <a:schemeClr val="accent1"/>
-          </a:lnRef>
-          <a:fillRef idx="3">
-            <a:schemeClr val="accent1"/>
-          </a:fillRef>
-          <a:effectRef idx="2">
-            <a:schemeClr val="accent1"/>
-          </a:effectRef>
-          <a:fontRef idx="minor">
-            <a:schemeClr val="lt1"/>
-          </a:fontRef>
-        </p:style>
-        <p:txBody>
-          <a:bodyPr rtlCol="0" anchor="ctr"/>
-          <a:lstStyle/>
-          <a:p>
-            <a:pPr algn="ctr"/>
-          </a:p>
-        </p:txBody>
-      </p:sp>
-      <p:sp>
-        <p:nvSpPr>
-          <p:cNvPr id="8" name="TextBox 7"/>
-          <p:cNvSpPr txBox="1"/>
-          <p:nvPr/>
-        </p:nvSpPr>
-        <p:spPr>
-          <a:xfrm>
-            <a:off x="347472" y="7461504"/>
-            <a:ext cx="6766560" cy="256032"/>
-          </a:xfrm>
-          <a:prstGeom prst="rect">
-            <a:avLst/>
-          </a:prstGeom>
-          <a:noFill/>
-        </p:spPr>
-        <p:txBody>
-          <a:bodyPr wrap="square" lIns="36576" rIns="36576" tIns="18288" bIns="18288" anchor="ctr"/>
-          <a:lstStyle/>
-          <a:p>
-            <a:pPr algn="l">
-              <a:spcAft>
-                <a:spcPts val="0"/>
-              </a:spcAft>
-            </a:pPr>
-            <a:r>
-              <a:rPr sz="1800" b="0" i="0">
-                <a:solidFill>
-                  <a:srgbClr val="1F3A5F"/>
-                </a:solidFill>
-                <a:latin typeface="Segoe UI"/>
-                <a:ea typeface="Segoe UI"/>
-                <a:cs typeface="Segoe UI"/>
-              </a:rPr>
-              <a:t>Monnot  ·  SIOP LEC 2026  ·  letter tile</a:t>
-            </a:r>
-          </a:p>
-        </p:txBody>
-      </p:sp>
-      <p:sp>
-        <p:nvSpPr>
-          <p:cNvPr id="9" name="TextBox 8"/>
-          <p:cNvSpPr txBox="1"/>
-          <p:nvPr/>
-        </p:nvSpPr>
-        <p:spPr>
-          <a:xfrm>
-            <a:off x="7223760" y="7461504"/>
-            <a:ext cx="2487168" cy="256032"/>
-          </a:xfrm>
-          <a:prstGeom prst="rect">
-            <a:avLst/>
-          </a:prstGeom>
-          <a:noFill/>
-        </p:spPr>
-        <p:txBody>
-          <a:bodyPr wrap="square" lIns="36576" rIns="36576" tIns="18288" bIns="18288" anchor="ctr"/>
-          <a:lstStyle/>
-          <a:p>
-            <a:pPr algn="r">
-              <a:spcAft>
-                <a:spcPts val="0"/>
-              </a:spcAft>
-            </a:pPr>
-            <a:r>
-              <a:rPr sz="1800" b="1" i="0">
-                <a:solidFill>
-                  <a:srgbClr val="1F3A5F"/>
-                </a:solidFill>
-                <a:latin typeface="Segoe UI"/>
-                <a:ea typeface="Segoe UI"/>
-                <a:cs typeface="Segoe UI"/>
-              </a:rPr>
-              <a:t>X3</a:t>
             </a:r>
           </a:p>
         </p:txBody>

</xml_diff>

<commit_message>
lec-2026: plain-language pass (set-aside cases, locked instructions, pass mark); Start here nav; friendlier index; deck v5 rebuilt
</commit_message>
<xml_diff>
--- a/lec-2026/assets/Monnot_Poster_v5.pptx
+++ b/lec-2026/assets/Monnot_Poster_v5.pptx
@@ -3391,8 +3391,8 @@
                 <a:ea typeface="Segoe UI"/>
                 <a:cs typeface="Segoe UI"/>
               </a:rPr>
-              <a:t>A two-wave field study and a governed AI coding pipeline
-for measuring meaning of work at scale.</a:t>
+              <a:t>A two-year field study, a governed test of AI text scoring,
+and ten years of nurses’ own forum talk.</a:t>
             </a:r>
           </a:p>
         </p:txBody>
@@ -3683,7 +3683,7 @@
                 <a:ea typeface="Segoe UI"/>
                 <a:cs typeface="Segoe UI"/>
               </a:rPr>
-              <a:t>The acceptance bars caught six prompts that looked precise</a:t>
+              <a:t>The pass mark caught six model setups that looked precise</a:t>
             </a:r>
           </a:p>
         </p:txBody>
@@ -3746,7 +3746,7 @@
                 <a:ea typeface="Segoe UI"/>
                 <a:cs typeface="Segoe UI"/>
               </a:rPr>
-              <a:t>Six frozen prompts, scored once on the 55-case development set, reached agency .750–.798 against a .910 bar and each over-called meaning on cells both humans coded absent, so none was admitted. A later 65-case out-of-sample look at the two best landed in the same range (Agency .81; Others .746–.770); 128 test cases stay sealed for the next instrument. Dimension-specific bars, a sealed holdout, and a false-positive disqualifier are the reusable deliverable.</a:t>
+              <a:t>Six sets of model instructions, locked and scored once on 55 try-out cases, reached agency .750–.798 against a pass mark of .910 and each found meaning the humans had not, so none was accepted. A later look at 65 unseen cases landed in the same range (agency .81; others .746–.770); 128 cases stay untouched. Reusable: a pass mark per dimension written first, cases set aside before tuning, an automatic fail for meaning the humans did not see.</a:t>
             </a:r>
           </a:p>
         </p:txBody>
@@ -4092,7 +4092,7 @@
               </a:spcAft>
             </a:pPr>
             <a:r>
-              <a:rPr sz="1300" b="0" i="1">
+              <a:rPr sz="1200" b="0" i="1">
                 <a:solidFill>
                   <a:srgbClr val="333333"/>
                 </a:solidFill>
@@ -4100,7 +4100,7 @@
                 <a:ea typeface="Segoe UI"/>
                 <a:cs typeface="Segoe UI"/>
               </a:rPr>
-              <a:t>Competence or mastery in the Time 1 story went with higher Time 2 turnover intentions (b = 1.40) and exhaustion (b = 0.95); 17 of 140 matched cases, holding a joint Time 1 survey battery. The pre-specified dimension paths sat near zero, which singles this code out. Exploratory; the lead for the next designed study.</a:t>
+              <a:t>Competence or mastery in the Time 1 story went with higher Time 2 turnover intentions (b = 1.40) and exhaustion (b = 0.95); 17 of 140 matched cases, after adjusting for the full Time 1 survey set. The planned paths from the broad meaning dimensions sat near zero, which singles this code out. Exploratory; the lead for the next designed study.</a:t>
             </a:r>
           </a:p>
         </p:txBody>
@@ -4555,7 +4555,7 @@
                 <a:ea typeface="Segoe UI"/>
                 <a:cs typeface="Segoe UI"/>
               </a:rPr>
-              <a:t>Seal a holdout before any prompt iteration.</a:t>
+              <a:t>Set aside a file of cases nobody scores until the model is final.</a:t>
             </a:r>
           </a:p>
         </p:txBody>
@@ -4676,7 +4676,7 @@
                 <a:ea typeface="Segoe UI"/>
                 <a:cs typeface="Segoe UI"/>
               </a:rPr>
-              <a:t>Pre-register the acceptance bar against a human benchmark.</a:t>
+              <a:t>Write the pass mark down first, from how well two humans agree.</a:t>
             </a:r>
           </a:p>
         </p:txBody>
@@ -4797,7 +4797,7 @@
                 <a:ea typeface="Segoe UI"/>
                 <a:cs typeface="Segoe UI"/>
               </a:rPr>
-              <a:t>Automate leakage + PII checks in CI.</a:t>
+              <a:t>Make the pipeline check itself: no set-aside cases in the practice pile, no names in the output.</a:t>
             </a:r>
           </a:p>
         </p:txBody>
@@ -5166,7 +5166,7 @@
                 <a:ea typeface="Segoe UI"/>
                 <a:cs typeface="Segoe UI"/>
               </a:rPr>
-              <a:t>•  Designed test of the competence → strain lead (n = 17 present cases).</a:t>
+              <a:t>•  A designed test of the competence → strain lead (17 cases so far).</a:t>
             </a:r>
           </a:p>
           <a:p>
@@ -5184,7 +5184,7 @@
                 <a:ea typeface="Segoe UI"/>
                 <a:cs typeface="Segoe UI"/>
               </a:rPr>
-              <a:t>•  Validate the forum event coder: second model, perturbations, negative controls, human check.</a:t>
+              <a:t>•  Check the forum model’s labels: a second model, reworded posts, posts that should score zero, and a human check.</a:t>
             </a:r>
           </a:p>
           <a:p>
@@ -5202,7 +5202,7 @@
                 <a:ea typeface="Segoe UI"/>
                 <a:cs typeface="Segoe UI"/>
               </a:rPr>
-              <a:t>•  Within-account lagged design: apparatus named in an earlier post, control loss or exit talk later.</a:t>
+              <a:t>•  Follow the same nurse over time: ratios or metrics named in an earlier post, loss of control or quit talk later.</a:t>
             </a:r>
           </a:p>
           <a:p>
@@ -5220,7 +5220,7 @@
                 <a:ea typeface="Segoe UI"/>
                 <a:cs typeface="Segoe UI"/>
               </a:rPr>
-              <a:t>•  Quasi-experimental test of AI adoption in helping work.</a:t>
+              <a:t>•  A before-and-after test of AI adoption in helping work, with exposure measured directly.</a:t>
             </a:r>
           </a:p>
         </p:txBody>
@@ -5671,7 +5671,7 @@
                 <a:ea typeface="Segoe UI"/>
                 <a:cs typeface="Segoe UI"/>
               </a:rPr>
-              <a:t>Plain-English one-pager on sealed holdouts, acceptance bars, and CI checks.</a:t>
+              <a:t>Plain-English one-pager: set-aside cases, pass marks written first, and automatic pipeline checks.</a:t>
             </a:r>
           </a:p>
         </p:txBody>
@@ -5792,7 +5792,7 @@
                 <a:ea typeface="Segoe UI"/>
                 <a:cs typeface="Segoe UI"/>
               </a:rPr>
-              <a:t>Locked split, pre-specified bars, and run provenance (model pin, prompt hash, git SHA).</a:t>
+              <a:t>How the cases were split, what the pass marks were, and the dated record of every run (model version, instructions, rules).</a:t>
             </a:r>
           </a:p>
         </p:txBody>
@@ -6259,7 +6259,7 @@
               </a:spcAft>
             </a:pPr>
             <a:r>
-              <a:rPr sz="1800" b="0" i="1">
+              <a:rPr sz="1600" b="0" i="1">
                 <a:solidFill>
                   <a:srgbClr val="333333"/>
                 </a:solidFill>
@@ -6267,7 +6267,7 @@
                 <a:ea typeface="Segoe UI"/>
                 <a:cs typeface="Segoe UI"/>
               </a:rPr>
-              <a:t>7,709 allnurses posts, capture years 2016–2026, one-model event codes. Seven named-AI events, none after 2021. Ratios, metrics, charting: one post in twenty across the decade. Lack-of-control flag +4 points (template-change caveat). One-model codes.</a:t>
+              <a:t>7,709 allnurses posts, archived 2016–2026, labels assigned by one model with no human check. Seven mentions of a named AI system, none after 2021. Ratios, metrics, charting: one post in twenty across the decade. Posts flagged for lack of control rose 4 points; a 2019–2021 site redesign sits under that rise, so hold it loosely.</a:t>
             </a:r>
           </a:p>
         </p:txBody>
@@ -6613,7 +6613,7 @@
               </a:spcAft>
             </a:pPr>
             <a:r>
-              <a:rPr sz="1800" b="0" i="1">
+              <a:rPr sz="1600" b="0" i="1">
                 <a:solidFill>
                   <a:srgbClr val="333333"/>
                 </a:solidFill>
@@ -6621,7 +6621,7 @@
                 <a:ea typeface="Segoe UI"/>
                 <a:cs typeface="Segoe UI"/>
               </a:rPr>
-              <a:t>Half of apparatus events land on Control/Autonomy; frustrated Control is the only facet cell that grew. Competence stays the most enacted facet. Role from credential badge at capture, 48% of posts. RN flat; APRN up with an interval through zero.</a:t>
+              <a:t>Half of the posts naming ratios, metrics, or charting land on control over how the work is done; frustrated control is the only category that grew. Competence stays the most-expressed source of meaning. Role comes from the credential badge on the post, 48% of posts. RNs flat; advanced practice up, with an interval that includes zero.</a:t>
             </a:r>
           </a:p>
         </p:txBody>
@@ -6904,7 +6904,7 @@
               </a:spcAft>
             </a:pPr>
             <a:r>
-              <a:rPr sz="2200" b="1" i="0">
+              <a:rPr sz="2000" b="1" i="0">
                 <a:solidFill>
                   <a:srgbClr val="FFFFFF"/>
                 </a:solidFill>
@@ -6912,7 +6912,7 @@
                 <a:ea typeface="Segoe UI"/>
                 <a:cs typeface="Segoe UI"/>
               </a:rPr>
-              <a:t>Concurrent meaning rises with code density, then levels</a:t>
+              <a:t>Survey meaning rises with the number of pathways in the story, then levels</a:t>
             </a:r>
           </a:p>
         </p:txBody>
@@ -6967,7 +6967,7 @@
               </a:spcAft>
             </a:pPr>
             <a:r>
-              <a:rPr sz="1400" b="0" i="1">
+              <a:rPr sz="1200" b="0" i="1">
                 <a:solidFill>
                   <a:srgbClr val="333333"/>
                 </a:solidFill>
@@ -6975,7 +6975,7 @@
                 <a:ea typeface="Segoe UI"/>
                 <a:cs typeface="Segoe UI"/>
               </a:rPr>
-              <a:t>Pathway density tracks Time 1 WAMI (others-directed r = .24; agency r = .20; contribution r = .23). Felt meaning rises from zero to two narrated pathways and flattens after; exploratory quadratic.</a:t>
+              <a:t>The more meaning pathways a story carries, the higher the same person’s survey meaning score (others-directed r = .24; agency r = .20; contribution r = .23). Felt meaning rises from zero to two pathways and levels off after; exploratory.</a:t>
             </a:r>
           </a:p>
         </p:txBody>
@@ -7258,7 +7258,7 @@
               </a:spcAft>
             </a:pPr>
             <a:r>
-              <a:rPr sz="2400" b="1" i="0">
+              <a:rPr sz="2200" b="1" i="0">
                 <a:solidFill>
                   <a:srgbClr val="FFFFFF"/>
                 </a:solidFill>
@@ -7266,7 +7266,7 @@
                 <a:ea typeface="Segoe UI"/>
                 <a:cs typeface="Segoe UI"/>
               </a:rPr>
-              <a:t>Frustrated control was the only forum cell that grew</a:t>
+              <a:t>Frustrated control was the only forum category that grew</a:t>
             </a:r>
           </a:p>
         </p:txBody>
@@ -7329,7 +7329,7 @@
                 <a:ea typeface="Segoe UI"/>
                 <a:cs typeface="Segoe UI"/>
               </a:rPr>
-              <a:t>Events per 100 posts, one-model codes. Competence most enacted; Control/Autonomy most frustrated and the only cell that grew. Communion spread across five thin, mostly enacted rows. One-model codes; capture year is the time axis.</a:t>
+              <a:t>Events per 100 posts, labels from one model with no human check. Competence is the most-expressed source of meaning; control over means the most frustrated and the only category that grew. Belonging and connection spread across five thin, mostly positive rows. The year is when the archive copy was taken.</a:t>
             </a:r>
           </a:p>
         </p:txBody>
@@ -8250,7 +8250,7 @@
                 <a:ea typeface="Segoe UI"/>
                 <a:cs typeface="Segoe UI"/>
               </a:rPr>
-              <a:t>•  This project tests whether that is possible — and how to govern it.</a:t>
+              <a:t>•  This project tests whether that is possible, and how to govern it.</a:t>
             </a:r>
           </a:p>
           <a:p>
@@ -8268,7 +8268,7 @@
                 <a:ea typeface="Segoe UI"/>
                 <a:cs typeface="Segoe UI"/>
               </a:rPr>
-              <a:t>•  Two-wave field study, a locked AI coding pipeline, and ten years of nurses' own talk.</a:t>
+              <a:t>•  A two-year field study, a locked test of AI text scoring, and ten years of nurses' own forum talk.</a:t>
             </a:r>
           </a:p>
         </p:txBody>
@@ -9017,7 +9017,7 @@
                 <a:ea typeface="Segoe UI"/>
                 <a:cs typeface="Segoe UI"/>
               </a:rPr>
-              <a:t>Rosso et al. (2010): four pathways to meaningful work, 13 mechanism facets.</a:t>
+              <a:t>Rosso et al. (2010): four pathways to meaningful work, 13 finer facets underneath them.</a:t>
             </a:r>
           </a:p>
         </p:txBody>
@@ -9347,7 +9347,7 @@
                 <a:ea typeface="Segoe UI"/>
                 <a:cs typeface="Segoe UI"/>
               </a:rPr>
-              <a:t>•  Additive vs. interactive combination of the four pathways.</a:t>
+              <a:t>•  Do the four pathways add up, or does one change what another does?</a:t>
             </a:r>
           </a:p>
           <a:p>
@@ -9365,7 +9365,7 @@
                 <a:ea typeface="Segoe UI"/>
                 <a:cs typeface="Segoe UI"/>
               </a:rPr>
-              <a:t>•  Possible plateau or curvilinear effect — too many active pathways may exhaust rather than sustain (Rosso et al., 2010, p. 116).</a:t>
+              <a:t>•  Is there a ceiling: can too many active pathways exhaust rather than sustain? (Rosso et al., 2010, p. 116)</a:t>
             </a:r>
           </a:p>
           <a:p>
@@ -9383,7 +9383,7 @@
                 <a:ea typeface="Segoe UI"/>
                 <a:cs typeface="Segoe UI"/>
               </a:rPr>
-              <a:t>•  Which pathways AI-driven redesign is most likely to strip.</a:t>
+              <a:t>•  Which pathways is AI-driven redesign most likely to strip?</a:t>
             </a:r>
           </a:p>
         </p:txBody>
@@ -9666,7 +9666,7 @@
               </a:spcAft>
             </a:pPr>
             <a:r>
-              <a:rPr sz="2700" b="1" i="0">
+              <a:rPr sz="2000" b="1" i="0">
                 <a:solidFill>
                   <a:srgbClr val="FFFFFF"/>
                 </a:solidFill>
@@ -9674,7 +9674,7 @@
                 <a:ea typeface="Segoe UI"/>
                 <a:cs typeface="Segoe UI"/>
               </a:rPr>
-              <a:t>Two waves, two coders, one sealed holdout</a:t>
+              <a:t>Two waves, two coders, and a set of cases nobody touched until the end</a:t>
             </a:r>
           </a:p>
         </p:txBody>
@@ -9737,7 +9737,7 @@
                 <a:ea typeface="Segoe UI"/>
                 <a:cs typeface="Segoe UI"/>
               </a:rPr>
-              <a:t>ML evaluation discipline, ported to survey research.</a:t>
+              <a:t>The discipline of a forecasting team, applied to survey research: write the pass mark first, set cases aside, look once.</a:t>
             </a:r>
           </a:p>
         </p:txBody>
@@ -10083,7 +10083,7 @@
               </a:spcAft>
             </a:pPr>
             <a:r>
-              <a:rPr sz="1800" b="0" i="1">
+              <a:rPr sz="1600" b="0" i="1">
                 <a:solidFill>
                   <a:srgbClr val="333333"/>
                 </a:solidFill>
@@ -10091,7 +10091,7 @@
                 <a:ea typeface="Segoe UI"/>
                 <a:cs typeface="Segoe UI"/>
               </a:rPr>
-              <a:t>Two trained human coders, 276 cases, dimension-level agreement.</a:t>
+              <a:t>How often two trained human coders agreed a kind of meaning was present, 276 stories. Agreement on agency is high; on belonging and connection it is near a coin flip.</a:t>
             </a:r>
           </a:p>
         </p:txBody>
@@ -10421,7 +10421,7 @@
                 <a:ea typeface="Segoe UI"/>
                 <a:cs typeface="Segoe UI"/>
               </a:rPr>
-              <a:t>•  Any vendor claiming to measure belonging or authenticity from text should be asked: against what human ceiling?</a:t>
+              <a:t>•  Any vendor claiming to measure belonging or authenticity from text should be asked: how well do two trained humans agree on it?</a:t>
             </a:r>
           </a:p>
           <a:p>
@@ -10439,7 +10439,7 @@
                 <a:ea typeface="Segoe UI"/>
                 <a:cs typeface="Segoe UI"/>
               </a:rPr>
-              <a:t>•  For communal meaning that ceiling is ~.5, not .9.</a:t>
+              <a:t>•  For belonging and connection the answer is about .5, not .9.</a:t>
             </a:r>
           </a:p>
           <a:p>
@@ -10457,7 +10457,7 @@
                 <a:ea typeface="Segoe UI"/>
                 <a:cs typeface="Segoe UI"/>
               </a:rPr>
-              <a:t>•  Validation targets must be dimension-specific.</a:t>
+              <a:t>•  Set a separate pass mark for each kind of meaning.</a:t>
             </a:r>
           </a:p>
           <a:p>
@@ -10475,7 +10475,7 @@
                 <a:ea typeface="Segoe UI"/>
                 <a:cs typeface="Segoe UI"/>
               </a:rPr>
-              <a:t>•  Agreement claims without a human benchmark are marketing.</a:t>
+              <a:t>•  Accuracy claims with no human comparison are marketing.</a:t>
             </a:r>
           </a:p>
         </p:txBody>

</xml_diff>

<commit_message>
lec-2026: Try this quarter rebuilt on work-design and algorithmic-management literature (two tracks, 12-week plan, vendor questions); Action tile updated
</commit_message>
<xml_diff>
--- a/lec-2026/assets/Monnot_Poster_v5.pptx
+++ b/lec-2026/assets/Monnot_Poster_v5.pptx
@@ -4447,7 +4447,7 @@
         </p:nvSpPr>
         <p:spPr>
           <a:xfrm>
-            <a:off x="502920" y="1463040"/>
+            <a:off x="502920" y="1490472"/>
             <a:ext cx="658368" cy="658368"/>
           </a:xfrm>
           <a:prstGeom prst="ellipse">
@@ -4490,7 +4490,7 @@
         </p:nvSpPr>
         <p:spPr>
           <a:xfrm>
-            <a:off x="502920" y="1463040"/>
+            <a:off x="502920" y="1490472"/>
             <a:ext cx="658368" cy="658368"/>
           </a:xfrm>
           <a:prstGeom prst="rect">
@@ -4529,7 +4529,7 @@
         </p:nvSpPr>
         <p:spPr>
           <a:xfrm>
-            <a:off x="1371600" y="1261872"/>
+            <a:off x="1371600" y="1216152"/>
             <a:ext cx="8275320" cy="1097280"/>
           </a:xfrm>
           <a:prstGeom prst="rect">
@@ -4547,7 +4547,7 @@
               </a:spcAft>
             </a:pPr>
             <a:r>
-              <a:rPr sz="2600" b="1" i="0">
+              <a:rPr sz="2100" b="1" i="0">
                 <a:solidFill>
                   <a:srgbClr val="FFFFFF"/>
                 </a:solidFill>
@@ -4555,20 +4555,59 @@
                 <a:ea typeface="Segoe UI"/>
                 <a:cs typeface="Segoe UI"/>
               </a:rPr>
-              <a:t>Set aside a file of cases nobody scores until the model is final.</a:t>
-            </a:r>
-          </a:p>
-        </p:txBody>
-      </p:sp>
-      <p:sp>
-        <p:nvSpPr>
-          <p:cNvPr id="9" name="Oval 8"/>
+              <a:t>Before you score employee text: set aside a file of comments nobody scores until the model is final, and write the pass mark first from how well two trained humans agree.</a:t>
+            </a:r>
+          </a:p>
+        </p:txBody>
+      </p:sp>
+      <p:sp>
+        <p:nvSpPr>
+          <p:cNvPr id="9" name="TextBox 8"/>
+          <p:cNvSpPr txBox="1"/>
+          <p:nvPr/>
+        </p:nvSpPr>
+        <p:spPr>
+          <a:xfrm>
+            <a:off x="1371600" y="2295144"/>
+            <a:ext cx="8275320" cy="329184"/>
+          </a:xfrm>
+          <a:prstGeom prst="rect">
+            <a:avLst/>
+          </a:prstGeom>
+          <a:noFill/>
+        </p:spPr>
+        <p:txBody>
+          <a:bodyPr wrap="square" lIns="36576" rIns="36576" tIns="18288" bIns="18288" anchor="t"/>
+          <a:lstStyle/>
+          <a:p>
+            <a:pPr algn="l">
+              <a:spcAft>
+                <a:spcPts val="0"/>
+              </a:spcAft>
+            </a:pPr>
+            <a:r>
+              <a:rPr sz="1300" b="0" i="1">
+                <a:solidFill>
+                  <a:srgbClr val="E4F2F2"/>
+                </a:solidFill>
+                <a:latin typeface="Segoe UI"/>
+                <a:ea typeface="Segoe UI"/>
+                <a:cs typeface="Segoe UI"/>
+              </a:rPr>
+              <a:t>Study 1; Törnberg (2024); Koenig et al. (2023)</a:t>
+            </a:r>
+          </a:p>
+        </p:txBody>
+      </p:sp>
+      <p:sp>
+        <p:nvSpPr>
+          <p:cNvPr id="10" name="Oval 9"/>
           <p:cNvSpPr/>
           <p:nvPr/>
         </p:nvSpPr>
         <p:spPr>
           <a:xfrm>
-            <a:off x="502920" y="2834640"/>
+            <a:off x="502920" y="3063240"/>
             <a:ext cx="658368" cy="658368"/>
           </a:xfrm>
           <a:prstGeom prst="ellipse">
@@ -4605,52 +4644,52 @@
       </p:sp>
       <p:sp>
         <p:nvSpPr>
-          <p:cNvPr id="10" name="TextBox 9"/>
-          <p:cNvSpPr txBox="1"/>
-          <p:nvPr/>
-        </p:nvSpPr>
-        <p:spPr>
-          <a:xfrm>
-            <a:off x="502920" y="2834640"/>
-            <a:ext cx="658368" cy="658368"/>
-          </a:xfrm>
-          <a:prstGeom prst="rect">
-            <a:avLst/>
-          </a:prstGeom>
-          <a:noFill/>
-        </p:spPr>
-        <p:txBody>
-          <a:bodyPr wrap="square" lIns="36576" rIns="36576" tIns="18288" bIns="18288" anchor="ctr"/>
-          <a:lstStyle/>
-          <a:p>
-            <a:pPr algn="ctr">
-              <a:spcAft>
-                <a:spcPts val="0"/>
-              </a:spcAft>
-            </a:pPr>
-            <a:r>
-              <a:rPr sz="2800" b="1" i="0">
-                <a:solidFill>
-                  <a:srgbClr val="FFFFFF"/>
-                </a:solidFill>
-                <a:latin typeface="Segoe UI"/>
-                <a:ea typeface="Segoe UI"/>
-                <a:cs typeface="Segoe UI"/>
-              </a:rPr>
-              <a:t>2</a:t>
-            </a:r>
-          </a:p>
-        </p:txBody>
-      </p:sp>
-      <p:sp>
-        <p:nvSpPr>
           <p:cNvPr id="11" name="TextBox 10"/>
           <p:cNvSpPr txBox="1"/>
           <p:nvPr/>
         </p:nvSpPr>
         <p:spPr>
           <a:xfrm>
-            <a:off x="1371600" y="2633472"/>
+            <a:off x="502920" y="3063240"/>
+            <a:ext cx="658368" cy="658368"/>
+          </a:xfrm>
+          <a:prstGeom prst="rect">
+            <a:avLst/>
+          </a:prstGeom>
+          <a:noFill/>
+        </p:spPr>
+        <p:txBody>
+          <a:bodyPr wrap="square" lIns="36576" rIns="36576" tIns="18288" bIns="18288" anchor="ctr"/>
+          <a:lstStyle/>
+          <a:p>
+            <a:pPr algn="ctr">
+              <a:spcAft>
+                <a:spcPts val="0"/>
+              </a:spcAft>
+            </a:pPr>
+            <a:r>
+              <a:rPr sz="2800" b="1" i="0">
+                <a:solidFill>
+                  <a:srgbClr val="FFFFFF"/>
+                </a:solidFill>
+                <a:latin typeface="Segoe UI"/>
+                <a:ea typeface="Segoe UI"/>
+                <a:cs typeface="Segoe UI"/>
+              </a:rPr>
+              <a:t>2</a:t>
+            </a:r>
+          </a:p>
+        </p:txBody>
+      </p:sp>
+      <p:sp>
+        <p:nvSpPr>
+          <p:cNvPr id="12" name="TextBox 11"/>
+          <p:cNvSpPr txBox="1"/>
+          <p:nvPr/>
+        </p:nvSpPr>
+        <p:spPr>
+          <a:xfrm>
+            <a:off x="1371600" y="2788920"/>
             <a:ext cx="8275320" cy="1097280"/>
           </a:xfrm>
           <a:prstGeom prst="rect">
@@ -4668,7 +4707,7 @@
               </a:spcAft>
             </a:pPr>
             <a:r>
-              <a:rPr sz="2600" b="1" i="0">
+              <a:rPr sz="2100" b="1" i="0">
                 <a:solidFill>
                   <a:srgbClr val="FFFFFF"/>
                 </a:solidFill>
@@ -4676,20 +4715,59 @@
                 <a:ea typeface="Segoe UI"/>
                 <a:cs typeface="Segoe UI"/>
               </a:rPr>
-              <a:t>Write the pass mark down first, from how well two humans agree.</a:t>
-            </a:r>
-          </a:p>
-        </p:txBody>
-      </p:sp>
-      <p:sp>
-        <p:nvSpPr>
-          <p:cNvPr id="12" name="Oval 11"/>
+              <a:t>Before you automate a task: map whose meaning it carries and whether the tool replaces it, leaves someone tending the machine, or amplifies the person.</a:t>
+            </a:r>
+          </a:p>
+        </p:txBody>
+      </p:sp>
+      <p:sp>
+        <p:nvSpPr>
+          <p:cNvPr id="13" name="TextBox 12"/>
+          <p:cNvSpPr txBox="1"/>
+          <p:nvPr/>
+        </p:nvSpPr>
+        <p:spPr>
+          <a:xfrm>
+            <a:off x="1371600" y="3867912"/>
+            <a:ext cx="8275320" cy="329184"/>
+          </a:xfrm>
+          <a:prstGeom prst="rect">
+            <a:avLst/>
+          </a:prstGeom>
+          <a:noFill/>
+        </p:spPr>
+        <p:txBody>
+          <a:bodyPr wrap="square" lIns="36576" rIns="36576" tIns="18288" bIns="18288" anchor="t"/>
+          <a:lstStyle/>
+          <a:p>
+            <a:pPr algn="l">
+              <a:spcAft>
+                <a:spcPts val="0"/>
+              </a:spcAft>
+            </a:pPr>
+            <a:r>
+              <a:rPr sz="1300" b="0" i="1">
+                <a:solidFill>
+                  <a:srgbClr val="E4F2F2"/>
+                </a:solidFill>
+                <a:latin typeface="Segoe UI"/>
+                <a:ea typeface="Segoe UI"/>
+                <a:cs typeface="Segoe UI"/>
+              </a:rPr>
+              <a:t>Bankins &amp; Formosa (2023); Parker &amp; Grote (2022)</a:t>
+            </a:r>
+          </a:p>
+        </p:txBody>
+      </p:sp>
+      <p:sp>
+        <p:nvSpPr>
+          <p:cNvPr id="14" name="Oval 13"/>
           <p:cNvSpPr/>
           <p:nvPr/>
         </p:nvSpPr>
         <p:spPr>
           <a:xfrm>
-            <a:off x="502920" y="4206240"/>
+            <a:off x="502920" y="4636008"/>
             <a:ext cx="658368" cy="658368"/>
           </a:xfrm>
           <a:prstGeom prst="ellipse">
@@ -4726,92 +4804,14 @@
       </p:sp>
       <p:sp>
         <p:nvSpPr>
-          <p:cNvPr id="13" name="TextBox 12"/>
-          <p:cNvSpPr txBox="1"/>
-          <p:nvPr/>
-        </p:nvSpPr>
-        <p:spPr>
-          <a:xfrm>
-            <a:off x="502920" y="4206240"/>
-            <a:ext cx="658368" cy="658368"/>
-          </a:xfrm>
-          <a:prstGeom prst="rect">
-            <a:avLst/>
-          </a:prstGeom>
-          <a:noFill/>
-        </p:spPr>
-        <p:txBody>
-          <a:bodyPr wrap="square" lIns="36576" rIns="36576" tIns="18288" bIns="18288" anchor="ctr"/>
-          <a:lstStyle/>
-          <a:p>
-            <a:pPr algn="ctr">
-              <a:spcAft>
-                <a:spcPts val="0"/>
-              </a:spcAft>
-            </a:pPr>
-            <a:r>
-              <a:rPr sz="2800" b="1" i="0">
-                <a:solidFill>
-                  <a:srgbClr val="FFFFFF"/>
-                </a:solidFill>
-                <a:latin typeface="Segoe UI"/>
-                <a:ea typeface="Segoe UI"/>
-                <a:cs typeface="Segoe UI"/>
-              </a:rPr>
-              <a:t>3</a:t>
-            </a:r>
-          </a:p>
-        </p:txBody>
-      </p:sp>
-      <p:sp>
-        <p:nvSpPr>
-          <p:cNvPr id="14" name="TextBox 13"/>
-          <p:cNvSpPr txBox="1"/>
-          <p:nvPr/>
-        </p:nvSpPr>
-        <p:spPr>
-          <a:xfrm>
-            <a:off x="1371600" y="4005072"/>
-            <a:ext cx="8275320" cy="1097280"/>
-          </a:xfrm>
-          <a:prstGeom prst="rect">
-            <a:avLst/>
-          </a:prstGeom>
-          <a:noFill/>
-        </p:spPr>
-        <p:txBody>
-          <a:bodyPr wrap="square" lIns="36576" rIns="36576" tIns="18288" bIns="18288" anchor="ctr"/>
-          <a:lstStyle/>
-          <a:p>
-            <a:pPr algn="l">
-              <a:spcAft>
-                <a:spcPts val="0"/>
-              </a:spcAft>
-            </a:pPr>
-            <a:r>
-              <a:rPr sz="2600" b="1" i="0">
-                <a:solidFill>
-                  <a:srgbClr val="FFFFFF"/>
-                </a:solidFill>
-                <a:latin typeface="Segoe UI"/>
-                <a:ea typeface="Segoe UI"/>
-                <a:cs typeface="Segoe UI"/>
-              </a:rPr>
-              <a:t>Make the pipeline check itself: no set-aside cases in the practice pile, no names in the output.</a:t>
-            </a:r>
-          </a:p>
-        </p:txBody>
-      </p:sp>
-      <p:sp>
-        <p:nvSpPr>
           <p:cNvPr id="15" name="TextBox 14"/>
           <p:cNvSpPr txBox="1"/>
           <p:nvPr/>
         </p:nvSpPr>
         <p:spPr>
           <a:xfrm>
-            <a:off x="411480" y="5989320"/>
-            <a:ext cx="9235440" cy="1097280"/>
+            <a:off x="502920" y="4636008"/>
+            <a:ext cx="658368" cy="658368"/>
           </a:xfrm>
           <a:prstGeom prst="rect">
             <a:avLst/>
@@ -4828,7 +4828,7 @@
               </a:spcAft>
             </a:pPr>
             <a:r>
-              <a:rPr sz="2200" b="0" i="1">
+              <a:rPr sz="2800" b="1" i="0">
                 <a:solidFill>
                   <a:srgbClr val="FFFFFF"/>
                 </a:solidFill>
@@ -4836,14 +4836,131 @@
                 <a:ea typeface="Segoe UI"/>
                 <a:cs typeface="Segoe UI"/>
               </a:rPr>
-              <a:t>Shaping the future of people analytics means governing it.</a:t>
-            </a:r>
-          </a:p>
-        </p:txBody>
-      </p:sp>
-      <p:sp>
-        <p:nvSpPr>
-          <p:cNvPr id="16" name="Rectangle 15"/>
+              <a:t>3</a:t>
+            </a:r>
+          </a:p>
+        </p:txBody>
+      </p:sp>
+      <p:sp>
+        <p:nvSpPr>
+          <p:cNvPr id="16" name="TextBox 15"/>
+          <p:cNvSpPr txBox="1"/>
+          <p:nvPr/>
+        </p:nvSpPr>
+        <p:spPr>
+          <a:xfrm>
+            <a:off x="1371600" y="4361688"/>
+            <a:ext cx="8275320" cy="1097280"/>
+          </a:xfrm>
+          <a:prstGeom prst="rect">
+            <a:avLst/>
+          </a:prstGeom>
+          <a:noFill/>
+        </p:spPr>
+        <p:txBody>
+          <a:bodyPr wrap="square" lIns="36576" rIns="36576" tIns="18288" bIns="18288" anchor="ctr"/>
+          <a:lstStyle/>
+          <a:p>
+            <a:pPr algn="l">
+              <a:spcAft>
+                <a:spcPts val="0"/>
+              </a:spcAft>
+            </a:pPr>
+            <a:r>
+              <a:rPr sz="2100" b="1" i="0">
+                <a:solidFill>
+                  <a:srgbClr val="FFFFFF"/>
+                </a:solidFill>
+                <a:latin typeface="Segoe UI"/>
+                <a:ea typeface="Segoe UI"/>
+                <a:cs typeface="Segoe UI"/>
+              </a:rPr>
+              <a:t>Pilot small with the people who do the work; keep the decision with the person; measure control and skill use, not only minutes saved.</a:t>
+            </a:r>
+          </a:p>
+        </p:txBody>
+      </p:sp>
+      <p:sp>
+        <p:nvSpPr>
+          <p:cNvPr id="17" name="TextBox 16"/>
+          <p:cNvSpPr txBox="1"/>
+          <p:nvPr/>
+        </p:nvSpPr>
+        <p:spPr>
+          <a:xfrm>
+            <a:off x="1371600" y="5440680"/>
+            <a:ext cx="8275320" cy="329184"/>
+          </a:xfrm>
+          <a:prstGeom prst="rect">
+            <a:avLst/>
+          </a:prstGeom>
+          <a:noFill/>
+        </p:spPr>
+        <p:txBody>
+          <a:bodyPr wrap="square" lIns="36576" rIns="36576" tIns="18288" bIns="18288" anchor="t"/>
+          <a:lstStyle/>
+          <a:p>
+            <a:pPr algn="l">
+              <a:spcAft>
+                <a:spcPts val="0"/>
+              </a:spcAft>
+            </a:pPr>
+            <a:r>
+              <a:rPr sz="1300" b="0" i="1">
+                <a:solidFill>
+                  <a:srgbClr val="E4F2F2"/>
+                </a:solidFill>
+                <a:latin typeface="Segoe UI"/>
+                <a:ea typeface="Segoe UI"/>
+                <a:cs typeface="Segoe UI"/>
+              </a:rPr>
+              <a:t>Bienefeld et al. (2025); Tierney et al. (2024); Shah et al. (2025); Studies 2–3</a:t>
+            </a:r>
+          </a:p>
+        </p:txBody>
+      </p:sp>
+      <p:sp>
+        <p:nvSpPr>
+          <p:cNvPr id="18" name="TextBox 17"/>
+          <p:cNvSpPr txBox="1"/>
+          <p:nvPr/>
+        </p:nvSpPr>
+        <p:spPr>
+          <a:xfrm>
+            <a:off x="411480" y="6263640"/>
+            <a:ext cx="9235440" cy="822960"/>
+          </a:xfrm>
+          <a:prstGeom prst="rect">
+            <a:avLst/>
+          </a:prstGeom>
+          <a:noFill/>
+        </p:spPr>
+        <p:txBody>
+          <a:bodyPr wrap="square" lIns="36576" rIns="36576" tIns="18288" bIns="18288" anchor="ctr"/>
+          <a:lstStyle/>
+          <a:p>
+            <a:pPr algn="ctr">
+              <a:spcAft>
+                <a:spcPts val="0"/>
+              </a:spcAft>
+            </a:pPr>
+            <a:r>
+              <a:rPr sz="1900" b="0" i="1">
+                <a:solidFill>
+                  <a:srgbClr val="FFFFFF"/>
+                </a:solidFill>
+                <a:latin typeface="Segoe UI"/>
+                <a:ea typeface="Segoe UI"/>
+                <a:cs typeface="Segoe UI"/>
+              </a:rPr>
+              <a:t>Shaping the future of people analytics means governing it. The twelve-week plan is in the goody bag.</a:t>
+            </a:r>
+          </a:p>
+        </p:txBody>
+      </p:sp>
+      <p:sp>
+        <p:nvSpPr>
+          <p:cNvPr id="19" name="Rectangle 18"/>
           <p:cNvSpPr/>
           <p:nvPr/>
         </p:nvSpPr>
@@ -4886,7 +5003,7 @@
       </p:sp>
       <p:sp>
         <p:nvSpPr>
-          <p:cNvPr id="17" name="TextBox 16"/>
+          <p:cNvPr id="20" name="TextBox 19"/>
           <p:cNvSpPr txBox="1"/>
           <p:nvPr/>
         </p:nvSpPr>
@@ -4925,7 +5042,7 @@
       </p:sp>
       <p:sp>
         <p:nvSpPr>
-          <p:cNvPr id="18" name="TextBox 17"/>
+          <p:cNvPr id="21" name="TextBox 20"/>
           <p:cNvSpPr txBox="1"/>
           <p:nvPr/>
         </p:nvSpPr>

</xml_diff>

<commit_message>
LEC 2026: design tile now shows field study, model test, and the nursing forum on one calendar
</commit_message>
<xml_diff>
--- a/lec-2026/assets/Monnot_Poster_v5.pptx
+++ b/lec-2026/assets/Monnot_Poster_v5.pptx
@@ -9052,7 +9052,7 @@
               </a:spcAft>
             </a:pPr>
             <a:r>
-              <a:rPr sz="2000" b="1" i="0">
+              <a:rPr sz="1800" b="1" i="0">
                 <a:solidFill>
                   <a:srgbClr val="1F3A5F"/>
                 </a:solidFill>
@@ -9060,7 +9060,7 @@
                 <a:ea typeface="Georgia"/>
                 <a:cs typeface="Georgia"/>
               </a:rPr>
-              <a:t>Two waves, two coders, and a set of cases nobody touched until the end</a:t>
+              <a:t>A two-year field study, a locked model test, and ten years of the forum</a:t>
             </a:r>
           </a:p>
         </p:txBody>
@@ -9115,7 +9115,7 @@
               </a:spcAft>
             </a:pPr>
             <a:r>
-              <a:rPr sz="1800" b="0" i="1">
+              <a:rPr sz="1600" b="0" i="1">
                 <a:solidFill>
                   <a:srgbClr val="2A2A2A"/>
                 </a:solidFill>
@@ -9123,7 +9123,7 @@
                 <a:ea typeface="Segoe UI"/>
                 <a:cs typeface="Segoe UI"/>
               </a:rPr>
-              <a:t>The discipline of a forecasting team, applied to survey research: write the pass mark first, set cases aside, look once.</a:t>
+              <a:t>One calendar. The field study writes the pass mark first and sets cases aside. The forum is the same decade, read later: 7,709 posts from Internet Archive snapshots, labels from one model.</a:t>
             </a:r>
           </a:p>
         </p:txBody>

</xml_diff>

<commit_message>
LEC 2026: design calendar uses ink, not pathway color
</commit_message>
<xml_diff>
--- a/lec-2026/assets/Monnot_Poster_v5.pptx
+++ b/lec-2026/assets/Monnot_Poster_v5.pptx
@@ -3597,7 +3597,7 @@
                 <a:ea typeface="Georgia"/>
                 <a:cs typeface="Georgia"/>
               </a:rPr>
-              <a:t>The pass mark caught six model setups that looked precise</a:t>
+              <a:t>None of six locked setups reached the agency bar</a:t>
             </a:r>
           </a:p>
         </p:txBody>
@@ -3660,7 +3660,7 @@
                 <a:ea typeface="Segoe UI"/>
                 <a:cs typeface="Segoe UI"/>
               </a:rPr>
-              <a:t>Six sets of model instructions, locked and scored once on 55 try-out cases, reached agency .750–.798 against a pass mark of .910 and each found meaning the humans had not, so none was accepted. A later look at 65 unseen cases landed in the same range (agency .81; others .746–.770); 128 cases stay untouched. Reusable: a pass mark per dimension written first, cases set aside before tuning, an automatic fail for meaning the humans did not see.</a:t>
+              <a:t>Six locked setups on 55 try-out cases: agency .750–.798 against a .910 bar. Highest agency .798 is .11 below the bar. Every setup also coded meaning both humans had marked absent (automatic fail). A later 65-case look stayed short on agency (.809 / .798); others-directed on the first of those dropped from .819 to .746, so the screen for the remaining 128 was not met and those cases stay sealed. Reusable: a pass mark per dimension written first, cases set aside before tuning, an automatic fail for meaning the humans did not see.</a:t>
             </a:r>
           </a:p>
         </p:txBody>

</xml_diff>

<commit_message>
lec-2026: deduplicated forum counts (7,695 posts, 5,429 events), regenerated trend data and Study 2 figures, deck rebuilt
</commit_message>
<xml_diff>
--- a/lec-2026/assets/Monnot_Poster_v5.pptx
+++ b/lec-2026/assets/Monnot_Poster_v5.pptx
@@ -3652,7 +3652,7 @@
               </a:spcAft>
             </a:pPr>
             <a:r>
-              <a:rPr sz="1200" b="0" i="1">
+              <a:rPr sz="1800" b="0" i="1">
                 <a:solidFill>
                   <a:srgbClr val="2A2A2A"/>
                 </a:solidFill>
@@ -3660,7 +3660,7 @@
                 <a:ea typeface="Segoe UI"/>
                 <a:cs typeface="Segoe UI"/>
               </a:rPr>
-              <a:t>Six locked setups on 55 try-out cases: agency .750–.798 against a .910 bar. Highest agency .798 is .11 below the bar. Every setup also coded meaning both humans had marked absent (automatic fail). A later 65-case look stayed short on agency (.809 / .798); others-directed on the first of those dropped from .819 to .746, so the screen for the remaining 128 was not met and those cases stay sealed. Reusable: a pass mark per dimension written first, cases set aside before tuning, an automatic fail for meaning the humans did not see.</a:t>
+              <a:t>None of six locked setups reached the agency bar. Agency .750–.798 against .910. Highest .798 is .11 below the bar.</a:t>
             </a:r>
           </a:p>
         </p:txBody>
@@ -5129,7 +5129,7 @@
                 <a:ea typeface="Segoe UI"/>
                 <a:cs typeface="Segoe UI"/>
               </a:rPr>
-              <a:t>•  Check the forum model’s labels: a second model, reworded posts, posts that should score zero, and a human check.</a:t>
+              <a:t>•  Code the 200-post transfer sheet, plus a second model, reworded posts, and posts that should score zero.</a:t>
             </a:r>
           </a:p>
           <a:p>
@@ -6083,7 +6083,7 @@
                 <a:ea typeface="Segoe UI"/>
                 <a:cs typeface="Segoe UI"/>
               </a:rPr>
-              <a:t>7,709 allnurses posts, archived 2016–2026, labels assigned by one model with no human check. Seven mentions of a named AI system, none after 2021. Ratios, metrics, charting: one post in twenty across the decade. Posts flagged for lack of control rose 4 points; a 2019–2021 site redesign sits under that rise, so hold it loosely.</a:t>
+              <a:t>7,695 allnurses posts, archived 2016–2026. The codebook is the one two humans built on the stories, applied here by one model. Seven mentions of a named AI system, none after 2021. Ratios, metrics, charting: one post in twenty across the decade. Posts flagged for lack of control rose 4 points; a 2019–2021 site redesign sits under that rise, so hold it loosely.</a:t>
             </a:r>
           </a:p>
         </p:txBody>
@@ -7016,7 +7016,7 @@
                 <a:ea typeface="Segoe UI"/>
                 <a:cs typeface="Segoe UI"/>
               </a:rPr>
-              <a:t>Events per 100 posts, labels from one model with no human check. Competence is the most-expressed source of meaning; control over means the most frustrated and the only category that grew. Belonging and connection spread across five thin, mostly positive rows. The year is when the archive copy was taken.</a:t>
+              <a:t>Events per 100 posts. Human-built codebook, applied by one model. Competence is the most-expressed source of meaning; control over means the most frustrated and the only category that grew. Belonging and connection spread across five thin, mostly positive rows. The year is when the archive copy was taken.</a:t>
             </a:r>
           </a:p>
         </p:txBody>
@@ -9123,7 +9123,7 @@
                 <a:ea typeface="Segoe UI"/>
                 <a:cs typeface="Segoe UI"/>
               </a:rPr>
-              <a:t>One calendar. The field study writes the pass mark first and sets cases aside. The forum is the same decade, read later: 7,709 posts from Internet Archive snapshots, labels from one model.</a:t>
+              <a:t>One calendar. The field study writes the pass mark first and sets cases aside. The forum is the same decade, read later: 7,695 posts from Internet Archive snapshots, labels from one model.</a:t>
             </a:r>
           </a:p>
         </p:txBody>

</xml_diff>